<commit_message>
Polish defense speech and clean up files
Refined Synkro_Defense_Speech.md: tightened wording throughout, clarified intro/agenda/roles/methodology, adjusted timing guidance (~14–15 min), and added practice notes. Replaced/updated Synkro_PFA_Defense.pptx. Renamed Synkro_PFA_Report_Adem_Ouerhani (7).docx → Synkro_PFA_Report_Adem_Ouerhani.docx. Removed leftover package for report.zip and temporary ~$nkro_PFA_Report_... lockfile. Documentation and assets only; no code changes.
</commit_message>
<xml_diff>
--- a/Synkro_PFA_Defense.pptx
+++ b/Synkro_PFA_Defense.pptx
@@ -2459,7 +2459,7 @@
     <p:bg>
       <p:bgPr>
         <a:solidFill>
-          <a:srgbClr val="14161F"/>
+          <a:srgbClr val="FFFFFF"/>
         </a:solidFill>
       </p:bgPr>
     </p:bg>
@@ -2477,266 +2477,2714 @@
           <a:chExt cx="0" cy="0"/>
         </a:xfrm>
       </p:grpSpPr>
-      <p:sp>
-        <p:nvSpPr>
-          <p:cNvPr id="2" name="Shape 0"/>
-          <p:cNvSpPr/>
-          <p:nvPr/>
-        </p:nvSpPr>
-        <p:spPr>
-          <a:xfrm>
-            <a:off x="7799832" y="1188720"/>
-            <a:ext cx="960120" cy="4023360"/>
-          </a:xfrm>
-          <a:prstGeom prst="rect">
-            <a:avLst/>
-          </a:prstGeom>
-          <a:solidFill>
-            <a:srgbClr val="1E212F"/>
-          </a:solidFill>
-          <a:ln w="9525">
+      <p:grpSp>
+        <p:nvGrpSpPr>
+          <p:cNvPr id="216" name="Synkro board illustration" descr="Illustration of the Synkro Kanban board with To Do, In Progress, In Review and Done columns"/>
+          <p:cNvGrpSpPr/>
+          <p:nvPr/>
+        </p:nvGrpSpPr>
+        <p:grpSpPr>
+          <a:xfrm>
+            <a:off x="6900000" y="1350000"/>
+            <a:ext cx="4651615" cy="4365000"/>
+            <a:chOff x="6900000" y="1350000"/>
+            <a:chExt cx="4651615" cy="4365000"/>
+          </a:xfrm>
+        </p:grpSpPr>
+        <p:sp>
+          <p:nvSpPr>
+            <p:cNvPr id="215" name="Board panel"/>
+            <p:cNvSpPr/>
+            <p:nvPr/>
+          </p:nvSpPr>
+          <p:spPr>
+            <a:xfrm>
+              <a:off x="6900000" y="1350000"/>
+              <a:ext cx="4651615" cy="4365000"/>
+            </a:xfrm>
+            <a:prstGeom prst="roundRect">
+              <a:avLst>
+                <a:gd name="adj" fmla="val 2749"/>
+              </a:avLst>
+            </a:prstGeom>
             <a:solidFill>
-              <a:srgbClr val="3E4258"/>
+              <a:srgbClr val="F4F5FA"/>
             </a:solidFill>
-            <a:prstDash val="solid"/>
-          </a:ln>
-        </p:spPr>
-      </p:sp>
-      <p:sp>
-        <p:nvSpPr>
-          <p:cNvPr id="3" name="Shape 1"/>
-          <p:cNvSpPr/>
-          <p:nvPr/>
-        </p:nvSpPr>
-        <p:spPr>
-          <a:xfrm>
-            <a:off x="7909560" y="1417320"/>
-            <a:ext cx="740664" cy="566928"/>
-          </a:xfrm>
-          <a:prstGeom prst="rect">
-            <a:avLst/>
-          </a:prstGeom>
-          <a:solidFill>
-            <a:srgbClr val="262A3C"/>
-          </a:solidFill>
-          <a:ln/>
-        </p:spPr>
-      </p:sp>
-      <p:sp>
-        <p:nvSpPr>
-          <p:cNvPr id="4" name="Shape 2"/>
-          <p:cNvSpPr/>
-          <p:nvPr/>
-        </p:nvSpPr>
-        <p:spPr>
-          <a:xfrm>
-            <a:off x="7909560" y="2130552"/>
-            <a:ext cx="740664" cy="566928"/>
-          </a:xfrm>
-          <a:prstGeom prst="rect">
-            <a:avLst/>
-          </a:prstGeom>
-          <a:solidFill>
-            <a:srgbClr val="262A3C"/>
-          </a:solidFill>
-          <a:ln/>
-        </p:spPr>
-      </p:sp>
-      <p:sp>
-        <p:nvSpPr>
-          <p:cNvPr id="5" name="Shape 3"/>
-          <p:cNvSpPr/>
-          <p:nvPr/>
-        </p:nvSpPr>
-        <p:spPr>
-          <a:xfrm>
-            <a:off x="8942832" y="1188720"/>
-            <a:ext cx="960120" cy="4023360"/>
-          </a:xfrm>
-          <a:prstGeom prst="rect">
-            <a:avLst/>
-          </a:prstGeom>
-          <a:solidFill>
-            <a:srgbClr val="1E212F"/>
-          </a:solidFill>
-          <a:ln w="9525">
+            <a:ln w="15875">
+              <a:solidFill>
+                <a:srgbClr val="9AA0B4"/>
+              </a:solidFill>
+            </a:ln>
+          </p:spPr>
+        </p:sp>
+        <p:sp>
+          <p:nvSpPr>
+            <p:cNvPr id="209" name="Board title"/>
+            <p:cNvSpPr txBox="1"/>
+            <p:nvPr/>
+          </p:nvSpPr>
+          <p:spPr>
+            <a:xfrm>
+              <a:off x="7040000" y="1510000"/>
+              <a:ext cx="1800000" cy="280000"/>
+            </a:xfrm>
+            <a:prstGeom prst="rect">
+              <a:avLst/>
+            </a:prstGeom>
+            <a:noFill/>
+            <a:ln>
+              <a:noFill/>
+            </a:ln>
+          </p:spPr>
+          <p:txBody>
+            <a:bodyPr wrap="none" lIns="0" tIns="0" rIns="0" bIns="0" rtlCol="0" anchor="ctr"/>
+            <a:lstStyle/>
+            <a:p>
+              <a:pPr algn="l"/>
+              <a:r>
+                <a:rPr lang="en-US" sz="1100" b="1" dirty="0">
+                  <a:solidFill>
+                    <a:srgbClr val="1E202B"/>
+                  </a:solidFill>
+                  <a:latin typeface="Calibri"/>
+                  <a:cs typeface="Calibri"/>
+                </a:rPr>
+                <a:t>Project board</a:t>
+              </a:r>
+            </a:p>
+          </p:txBody>
+        </p:sp>
+        <p:sp>
+          <p:nvSpPr>
+            <p:cNvPr id="210" name="Member 1"/>
+            <p:cNvSpPr/>
+            <p:nvPr/>
+          </p:nvSpPr>
+          <p:spPr>
+            <a:xfrm>
+              <a:off x="10851615" y="1530000"/>
+              <a:ext cx="240000" cy="240000"/>
+            </a:xfrm>
+            <a:prstGeom prst="ellipse">
+              <a:avLst/>
+            </a:prstGeom>
             <a:solidFill>
-              <a:srgbClr val="3E4258"/>
+              <a:srgbClr val="6366F1"/>
             </a:solidFill>
-            <a:prstDash val="solid"/>
-          </a:ln>
-        </p:spPr>
-      </p:sp>
-      <p:sp>
-        <p:nvSpPr>
-          <p:cNvPr id="6" name="Shape 4"/>
-          <p:cNvSpPr/>
-          <p:nvPr/>
-        </p:nvSpPr>
-        <p:spPr>
-          <a:xfrm>
-            <a:off x="9052560" y="1417320"/>
-            <a:ext cx="740664" cy="566928"/>
-          </a:xfrm>
-          <a:prstGeom prst="rect">
-            <a:avLst/>
-          </a:prstGeom>
-          <a:solidFill>
-            <a:srgbClr val="262A3C"/>
-          </a:solidFill>
-          <a:ln/>
-        </p:spPr>
-      </p:sp>
-      <p:sp>
-        <p:nvSpPr>
-          <p:cNvPr id="7" name="Shape 5"/>
-          <p:cNvSpPr/>
-          <p:nvPr/>
-        </p:nvSpPr>
-        <p:spPr>
-          <a:xfrm>
-            <a:off x="9052560" y="2130552"/>
-            <a:ext cx="740664" cy="566928"/>
-          </a:xfrm>
-          <a:prstGeom prst="rect">
-            <a:avLst/>
-          </a:prstGeom>
-          <a:solidFill>
-            <a:srgbClr val="262A3C"/>
-          </a:solidFill>
-          <a:ln/>
-        </p:spPr>
-      </p:sp>
-      <p:sp>
-        <p:nvSpPr>
-          <p:cNvPr id="8" name="Shape 6"/>
-          <p:cNvSpPr/>
-          <p:nvPr/>
-        </p:nvSpPr>
-        <p:spPr>
-          <a:xfrm>
-            <a:off x="9052560" y="2843784"/>
-            <a:ext cx="740664" cy="566928"/>
-          </a:xfrm>
-          <a:prstGeom prst="rect">
-            <a:avLst/>
-          </a:prstGeom>
-          <a:solidFill>
-            <a:srgbClr val="262A3C"/>
-          </a:solidFill>
-          <a:ln/>
-        </p:spPr>
-      </p:sp>
-      <p:sp>
-        <p:nvSpPr>
-          <p:cNvPr id="9" name="Shape 7"/>
-          <p:cNvSpPr/>
-          <p:nvPr/>
-        </p:nvSpPr>
-        <p:spPr>
-          <a:xfrm>
-            <a:off x="10085832" y="1188720"/>
-            <a:ext cx="960120" cy="4023360"/>
-          </a:xfrm>
-          <a:prstGeom prst="rect">
-            <a:avLst/>
-          </a:prstGeom>
-          <a:solidFill>
-            <a:srgbClr val="1E212F"/>
-          </a:solidFill>
-          <a:ln w="9525">
+            <a:ln w="19050">
+              <a:solidFill>
+                <a:srgbClr val="F4F5FA"/>
+              </a:solidFill>
+            </a:ln>
+          </p:spPr>
+        </p:sp>
+        <p:sp>
+          <p:nvSpPr>
+            <p:cNvPr id="211" name="Member 2"/>
+            <p:cNvSpPr/>
+            <p:nvPr/>
+          </p:nvSpPr>
+          <p:spPr>
+            <a:xfrm>
+              <a:off x="11011615" y="1530000"/>
+              <a:ext cx="240000" cy="240000"/>
+            </a:xfrm>
+            <a:prstGeom prst="ellipse">
+              <a:avLst/>
+            </a:prstGeom>
             <a:solidFill>
-              <a:srgbClr val="3E4258"/>
+              <a:srgbClr val="14B8A6"/>
             </a:solidFill>
-            <a:prstDash val="solid"/>
-          </a:ln>
-        </p:spPr>
-      </p:sp>
-      <p:sp>
-        <p:nvSpPr>
-          <p:cNvPr id="10" name="Shape 8"/>
-          <p:cNvSpPr/>
-          <p:nvPr/>
-        </p:nvSpPr>
-        <p:spPr>
-          <a:xfrm>
-            <a:off x="10195560" y="1417320"/>
-            <a:ext cx="740664" cy="566928"/>
-          </a:xfrm>
-          <a:prstGeom prst="rect">
-            <a:avLst/>
-          </a:prstGeom>
-          <a:solidFill>
-            <a:srgbClr val="262A3C"/>
-          </a:solidFill>
-          <a:ln/>
-        </p:spPr>
-      </p:sp>
-      <p:sp>
-        <p:nvSpPr>
-          <p:cNvPr id="11" name="Shape 9"/>
-          <p:cNvSpPr/>
-          <p:nvPr/>
-        </p:nvSpPr>
-        <p:spPr>
-          <a:xfrm>
-            <a:off x="11228832" y="1188720"/>
-            <a:ext cx="960120" cy="4023360"/>
-          </a:xfrm>
-          <a:prstGeom prst="rect">
-            <a:avLst/>
-          </a:prstGeom>
-          <a:solidFill>
-            <a:srgbClr val="1E212F"/>
-          </a:solidFill>
-          <a:ln w="9525">
+            <a:ln w="19050">
+              <a:solidFill>
+                <a:srgbClr val="F4F5FA"/>
+              </a:solidFill>
+            </a:ln>
+          </p:spPr>
+        </p:sp>
+        <p:sp>
+          <p:nvSpPr>
+            <p:cNvPr id="212" name="Member 3"/>
+            <p:cNvSpPr/>
+            <p:nvPr/>
+          </p:nvSpPr>
+          <p:spPr>
+            <a:xfrm>
+              <a:off x="11171615" y="1530000"/>
+              <a:ext cx="240000" cy="240000"/>
+            </a:xfrm>
+            <a:prstGeom prst="ellipse">
+              <a:avLst/>
+            </a:prstGeom>
             <a:solidFill>
-              <a:srgbClr val="3E4258"/>
+              <a:srgbClr val="EC4899"/>
             </a:solidFill>
-            <a:prstDash val="solid"/>
-          </a:ln>
-        </p:spPr>
-      </p:sp>
-      <p:sp>
-        <p:nvSpPr>
-          <p:cNvPr id="12" name="Shape 10"/>
-          <p:cNvSpPr/>
-          <p:nvPr/>
-        </p:nvSpPr>
-        <p:spPr>
-          <a:xfrm>
-            <a:off x="11338560" y="1417320"/>
-            <a:ext cx="740664" cy="566928"/>
-          </a:xfrm>
-          <a:prstGeom prst="rect">
-            <a:avLst/>
-          </a:prstGeom>
-          <a:solidFill>
-            <a:srgbClr val="262A3C"/>
-          </a:solidFill>
-          <a:ln/>
-        </p:spPr>
-      </p:sp>
-      <p:sp>
-        <p:nvSpPr>
-          <p:cNvPr id="13" name="Shape 11"/>
-          <p:cNvSpPr/>
-          <p:nvPr/>
-        </p:nvSpPr>
-        <p:spPr>
-          <a:xfrm>
-            <a:off x="11338560" y="2130552"/>
-            <a:ext cx="740664" cy="566928"/>
-          </a:xfrm>
-          <a:prstGeom prst="rect">
-            <a:avLst/>
-          </a:prstGeom>
-          <a:solidFill>
-            <a:srgbClr val="262A3C"/>
-          </a:solidFill>
-          <a:ln/>
-        </p:spPr>
-      </p:sp>
+            <a:ln w="19050">
+              <a:solidFill>
+                <a:srgbClr val="F4F5FA"/>
+              </a:solidFill>
+            </a:ln>
+          </p:spPr>
+        </p:sp>
+        <p:sp>
+          <p:nvSpPr>
+            <p:cNvPr id="213" name="Live dot"/>
+            <p:cNvSpPr/>
+            <p:nvPr/>
+          </p:nvSpPr>
+          <p:spPr>
+            <a:xfrm>
+              <a:off x="10241615" y="1610000"/>
+              <a:ext cx="80000" cy="80000"/>
+            </a:xfrm>
+            <a:prstGeom prst="ellipse">
+              <a:avLst/>
+            </a:prstGeom>
+            <a:solidFill>
+              <a:srgbClr val="22C55E"/>
+            </a:solidFill>
+            <a:ln>
+              <a:noFill/>
+            </a:ln>
+          </p:spPr>
+        </p:sp>
+        <p:sp>
+          <p:nvSpPr>
+            <p:cNvPr id="214" name="Live label"/>
+            <p:cNvSpPr txBox="1"/>
+            <p:nvPr/>
+          </p:nvSpPr>
+          <p:spPr>
+            <a:xfrm>
+              <a:off x="10371615" y="1510000"/>
+              <a:ext cx="320000" cy="280000"/>
+            </a:xfrm>
+            <a:prstGeom prst="rect">
+              <a:avLst/>
+            </a:prstGeom>
+            <a:noFill/>
+            <a:ln>
+              <a:noFill/>
+            </a:ln>
+          </p:spPr>
+          <p:txBody>
+            <a:bodyPr wrap="none" lIns="0" tIns="0" rIns="0" bIns="0" rtlCol="0" anchor="ctr"/>
+            <a:lstStyle/>
+            <a:p>
+              <a:pPr algn="l"/>
+              <a:r>
+                <a:rPr lang="en-US" sz="1000" b="0" dirty="0">
+                  <a:solidFill>
+                    <a:srgbClr val="484C5C"/>
+                  </a:solidFill>
+                  <a:latin typeface="Calibri"/>
+                  <a:cs typeface="Calibri"/>
+                </a:rPr>
+                <a:t>Live</a:t>
+              </a:r>
+            </a:p>
+          </p:txBody>
+        </p:sp>
+        <p:grpSp>
+          <p:nvGrpSpPr>
+            <p:cNvPr id="132" name="Column – To Do"/>
+            <p:cNvGrpSpPr/>
+            <p:nvPr/>
+          </p:nvGrpSpPr>
+          <p:grpSpPr>
+            <a:xfrm>
+              <a:off x="7040000" y="1950000"/>
+              <a:ext cx="1025404" cy="3625000"/>
+              <a:chOff x="7040000" y="1950000"/>
+              <a:chExt cx="1025404" cy="3625000"/>
+            </a:xfrm>
+          </p:grpSpPr>
+          <p:sp>
+            <p:nvSpPr>
+              <p:cNvPr id="101" name="Column To Do"/>
+              <p:cNvSpPr/>
+              <p:nvPr/>
+            </p:nvSpPr>
+            <p:spPr>
+              <a:xfrm>
+                <a:off x="7040000" y="1950000"/>
+                <a:ext cx="1025404" cy="3625000"/>
+              </a:xfrm>
+              <a:prstGeom prst="roundRect">
+                <a:avLst>
+                  <a:gd name="adj" fmla="val 5851"/>
+                </a:avLst>
+              </a:prstGeom>
+              <a:solidFill>
+                <a:srgbClr val="E4E7F2"/>
+              </a:solidFill>
+              <a:ln>
+                <a:noFill/>
+              </a:ln>
+            </p:spPr>
+          </p:sp>
+          <p:sp>
+            <p:nvSpPr>
+              <p:cNvPr id="102" name="Status dot"/>
+              <p:cNvSpPr/>
+              <p:nvPr/>
+            </p:nvSpPr>
+            <p:spPr>
+              <a:xfrm>
+                <a:off x="7140000" y="2095000"/>
+                <a:ext cx="90000" cy="90000"/>
+              </a:xfrm>
+              <a:prstGeom prst="ellipse">
+                <a:avLst/>
+              </a:prstGeom>
+              <a:solidFill>
+                <a:srgbClr val="6B7194"/>
+              </a:solidFill>
+              <a:ln>
+                <a:noFill/>
+              </a:ln>
+            </p:spPr>
+          </p:sp>
+          <p:sp>
+            <p:nvSpPr>
+              <p:cNvPr id="103" name="Column label"/>
+              <p:cNvSpPr txBox="1"/>
+              <p:nvPr/>
+            </p:nvSpPr>
+            <p:spPr>
+              <a:xfrm>
+                <a:off x="7300000" y="2050000"/>
+                <a:ext cx="725404" cy="180000"/>
+              </a:xfrm>
+              <a:prstGeom prst="rect">
+                <a:avLst/>
+              </a:prstGeom>
+              <a:noFill/>
+              <a:ln>
+                <a:noFill/>
+              </a:ln>
+            </p:spPr>
+            <p:txBody>
+              <a:bodyPr wrap="none" lIns="0" tIns="0" rIns="0" bIns="0" rtlCol="0" anchor="ctr"/>
+              <a:lstStyle/>
+              <a:p>
+                <a:pPr algn="l"/>
+                <a:r>
+                  <a:rPr lang="en-US" sz="1000" b="1" dirty="0">
+                    <a:solidFill>
+                      <a:srgbClr val="1E202B"/>
+                    </a:solidFill>
+                    <a:latin typeface="Calibri"/>
+                    <a:cs typeface="Calibri"/>
+                  </a:rPr>
+                  <a:t>To Do</a:t>
+                </a:r>
+              </a:p>
+            </p:txBody>
+          </p:sp>
+          <p:grpSp>
+            <p:nvGrpSpPr>
+              <p:cNvPr id="110" name="Task card"/>
+              <p:cNvGrpSpPr/>
+              <p:nvPr/>
+            </p:nvGrpSpPr>
+            <p:grpSpPr>
+              <a:xfrm>
+                <a:off x="7115000" y="2370000"/>
+                <a:ext cx="875404" cy="680000"/>
+                <a:chOff x="7115000" y="2370000"/>
+                <a:chExt cx="875404" cy="680000"/>
+              </a:xfrm>
+            </p:grpSpPr>
+            <p:sp>
+              <p:nvSpPr>
+                <p:cNvPr id="104" name="Card"/>
+                <p:cNvSpPr/>
+                <p:nvPr/>
+              </p:nvSpPr>
+              <p:spPr>
+                <a:xfrm>
+                  <a:off x="7115000" y="2370000"/>
+                  <a:ext cx="875404" cy="680000"/>
+                </a:xfrm>
+                <a:prstGeom prst="roundRect">
+                  <a:avLst>
+                    <a:gd name="adj" fmla="val 7352"/>
+                  </a:avLst>
+                </a:prstGeom>
+                <a:solidFill>
+                  <a:srgbClr val="FFFFFF"/>
+                </a:solidFill>
+                <a:ln w="12700">
+                  <a:solidFill>
+                    <a:srgbClr val="9AA0B4"/>
+                  </a:solidFill>
+                </a:ln>
+              </p:spPr>
+            </p:sp>
+            <p:sp>
+              <p:nvSpPr>
+                <p:cNvPr id="105" name="Tag"/>
+                <p:cNvSpPr/>
+                <p:nvPr/>
+              </p:nvSpPr>
+              <p:spPr>
+                <a:xfrm>
+                  <a:off x="7205000" y="2470000"/>
+                  <a:ext cx="280000" cy="70000"/>
+                </a:xfrm>
+                <a:prstGeom prst="roundRect">
+                  <a:avLst>
+                    <a:gd name="adj" fmla="val 50000"/>
+                  </a:avLst>
+                </a:prstGeom>
+                <a:solidFill>
+                  <a:srgbClr val="4F46E5"/>
+                </a:solidFill>
+                <a:ln>
+                  <a:noFill/>
+                </a:ln>
+              </p:spPr>
+            </p:sp>
+            <p:sp>
+              <p:nvSpPr>
+                <p:cNvPr id="106" name="Title line"/>
+                <p:cNvSpPr/>
+                <p:nvPr/>
+              </p:nvSpPr>
+              <p:spPr>
+                <a:xfrm>
+                  <a:off x="7205000" y="2610000"/>
+                  <a:ext cx="694400" cy="55000"/>
+                </a:xfrm>
+                <a:prstGeom prst="roundRect">
+                  <a:avLst>
+                    <a:gd name="adj" fmla="val 50000"/>
+                  </a:avLst>
+                </a:prstGeom>
+                <a:solidFill>
+                  <a:srgbClr val="484C5C"/>
+                </a:solidFill>
+                <a:ln>
+                  <a:noFill/>
+                </a:ln>
+              </p:spPr>
+            </p:sp>
+            <p:sp>
+              <p:nvSpPr>
+                <p:cNvPr id="107" name="Detail line"/>
+                <p:cNvSpPr/>
+                <p:nvPr/>
+              </p:nvSpPr>
+              <p:spPr>
+                <a:xfrm>
+                  <a:off x="7205000" y="2710000"/>
+                  <a:ext cx="448000" cy="45000"/>
+                </a:xfrm>
+                <a:prstGeom prst="roundRect">
+                  <a:avLst>
+                    <a:gd name="adj" fmla="val 50000"/>
+                  </a:avLst>
+                </a:prstGeom>
+                <a:solidFill>
+                  <a:srgbClr val="A3A8BC"/>
+                </a:solidFill>
+                <a:ln>
+                  <a:noFill/>
+                </a:ln>
+              </p:spPr>
+            </p:sp>
+            <p:sp>
+              <p:nvSpPr>
+                <p:cNvPr id="108" name="Checklist track"/>
+                <p:cNvSpPr/>
+                <p:nvPr/>
+              </p:nvSpPr>
+              <p:spPr>
+                <a:xfrm>
+                  <a:off x="7205000" y="2900000"/>
+                  <a:ext cx="420000" cy="45000"/>
+                </a:xfrm>
+                <a:prstGeom prst="roundRect">
+                  <a:avLst>
+                    <a:gd name="adj" fmla="val 50000"/>
+                  </a:avLst>
+                </a:prstGeom>
+                <a:solidFill>
+                  <a:srgbClr val="D0D3E0"/>
+                </a:solidFill>
+                <a:ln>
+                  <a:noFill/>
+                </a:ln>
+              </p:spPr>
+            </p:sp>
+            <p:sp>
+              <p:nvSpPr>
+                <p:cNvPr id="109" name="Assignee"/>
+                <p:cNvSpPr/>
+                <p:nvPr/>
+              </p:nvSpPr>
+              <p:spPr>
+                <a:xfrm>
+                  <a:off x="7760404" y="2840000"/>
+                  <a:ext cx="140000" cy="140000"/>
+                </a:xfrm>
+                <a:prstGeom prst="ellipse">
+                  <a:avLst/>
+                </a:prstGeom>
+                <a:solidFill>
+                  <a:srgbClr val="6366F1"/>
+                </a:solidFill>
+                <a:ln>
+                  <a:noFill/>
+                </a:ln>
+              </p:spPr>
+            </p:sp>
+          </p:grpSp>
+          <p:grpSp>
+            <p:nvGrpSpPr>
+              <p:cNvPr id="117" name="Task card"/>
+              <p:cNvGrpSpPr/>
+              <p:nvPr/>
+            </p:nvGrpSpPr>
+            <p:grpSpPr>
+              <a:xfrm>
+                <a:off x="7115000" y="3160000"/>
+                <a:ext cx="875404" cy="680000"/>
+                <a:chOff x="7115000" y="3160000"/>
+                <a:chExt cx="875404" cy="680000"/>
+              </a:xfrm>
+            </p:grpSpPr>
+            <p:sp>
+              <p:nvSpPr>
+                <p:cNvPr id="111" name="Card"/>
+                <p:cNvSpPr/>
+                <p:nvPr/>
+              </p:nvSpPr>
+              <p:spPr>
+                <a:xfrm>
+                  <a:off x="7115000" y="3160000"/>
+                  <a:ext cx="875404" cy="680000"/>
+                </a:xfrm>
+                <a:prstGeom prst="roundRect">
+                  <a:avLst>
+                    <a:gd name="adj" fmla="val 7352"/>
+                  </a:avLst>
+                </a:prstGeom>
+                <a:solidFill>
+                  <a:srgbClr val="FFFFFF"/>
+                </a:solidFill>
+                <a:ln w="12700">
+                  <a:solidFill>
+                    <a:srgbClr val="9AA0B4"/>
+                  </a:solidFill>
+                </a:ln>
+              </p:spPr>
+            </p:sp>
+            <p:sp>
+              <p:nvSpPr>
+                <p:cNvPr id="112" name="Tag"/>
+                <p:cNvSpPr/>
+                <p:nvPr/>
+              </p:nvSpPr>
+              <p:spPr>
+                <a:xfrm>
+                  <a:off x="7205000" y="3260000"/>
+                  <a:ext cx="280000" cy="70000"/>
+                </a:xfrm>
+                <a:prstGeom prst="roundRect">
+                  <a:avLst>
+                    <a:gd name="adj" fmla="val 50000"/>
+                  </a:avLst>
+                </a:prstGeom>
+                <a:solidFill>
+                  <a:srgbClr val="0D9488"/>
+                </a:solidFill>
+                <a:ln>
+                  <a:noFill/>
+                </a:ln>
+              </p:spPr>
+            </p:sp>
+            <p:sp>
+              <p:nvSpPr>
+                <p:cNvPr id="113" name="Title line"/>
+                <p:cNvSpPr/>
+                <p:nvPr/>
+              </p:nvSpPr>
+              <p:spPr>
+                <a:xfrm>
+                  <a:off x="7205000" y="3400000"/>
+                  <a:ext cx="560000" cy="55000"/>
+                </a:xfrm>
+                <a:prstGeom prst="roundRect">
+                  <a:avLst>
+                    <a:gd name="adj" fmla="val 50000"/>
+                  </a:avLst>
+                </a:prstGeom>
+                <a:solidFill>
+                  <a:srgbClr val="484C5C"/>
+                </a:solidFill>
+                <a:ln>
+                  <a:noFill/>
+                </a:ln>
+              </p:spPr>
+            </p:sp>
+            <p:sp>
+              <p:nvSpPr>
+                <p:cNvPr id="114" name="Detail line"/>
+                <p:cNvSpPr/>
+                <p:nvPr/>
+              </p:nvSpPr>
+              <p:spPr>
+                <a:xfrm>
+                  <a:off x="7205000" y="3500000"/>
+                  <a:ext cx="336000" cy="45000"/>
+                </a:xfrm>
+                <a:prstGeom prst="roundRect">
+                  <a:avLst>
+                    <a:gd name="adj" fmla="val 50000"/>
+                  </a:avLst>
+                </a:prstGeom>
+                <a:solidFill>
+                  <a:srgbClr val="A3A8BC"/>
+                </a:solidFill>
+                <a:ln>
+                  <a:noFill/>
+                </a:ln>
+              </p:spPr>
+            </p:sp>
+            <p:sp>
+              <p:nvSpPr>
+                <p:cNvPr id="115" name="Checklist track"/>
+                <p:cNvSpPr/>
+                <p:nvPr/>
+              </p:nvSpPr>
+              <p:spPr>
+                <a:xfrm>
+                  <a:off x="7205000" y="3690000"/>
+                  <a:ext cx="420000" cy="45000"/>
+                </a:xfrm>
+                <a:prstGeom prst="roundRect">
+                  <a:avLst>
+                    <a:gd name="adj" fmla="val 50000"/>
+                  </a:avLst>
+                </a:prstGeom>
+                <a:solidFill>
+                  <a:srgbClr val="D0D3E0"/>
+                </a:solidFill>
+                <a:ln>
+                  <a:noFill/>
+                </a:ln>
+              </p:spPr>
+            </p:sp>
+            <p:sp>
+              <p:nvSpPr>
+                <p:cNvPr id="116" name="Assignee"/>
+                <p:cNvSpPr/>
+                <p:nvPr/>
+              </p:nvSpPr>
+              <p:spPr>
+                <a:xfrm>
+                  <a:off x="7760404" y="3630000"/>
+                  <a:ext cx="140000" cy="140000"/>
+                </a:xfrm>
+                <a:prstGeom prst="ellipse">
+                  <a:avLst/>
+                </a:prstGeom>
+                <a:solidFill>
+                  <a:srgbClr val="EC4899"/>
+                </a:solidFill>
+                <a:ln>
+                  <a:noFill/>
+                </a:ln>
+              </p:spPr>
+            </p:sp>
+          </p:grpSp>
+          <p:grpSp>
+            <p:nvGrpSpPr>
+              <p:cNvPr id="124" name="Task card"/>
+              <p:cNvGrpSpPr/>
+              <p:nvPr/>
+            </p:nvGrpSpPr>
+            <p:grpSpPr>
+              <a:xfrm>
+                <a:off x="7115000" y="3950000"/>
+                <a:ext cx="875404" cy="680000"/>
+                <a:chOff x="7115000" y="3950000"/>
+                <a:chExt cx="875404" cy="680000"/>
+              </a:xfrm>
+            </p:grpSpPr>
+            <p:sp>
+              <p:nvSpPr>
+                <p:cNvPr id="118" name="Card"/>
+                <p:cNvSpPr/>
+                <p:nvPr/>
+              </p:nvSpPr>
+              <p:spPr>
+                <a:xfrm>
+                  <a:off x="7115000" y="3950000"/>
+                  <a:ext cx="875404" cy="680000"/>
+                </a:xfrm>
+                <a:prstGeom prst="roundRect">
+                  <a:avLst>
+                    <a:gd name="adj" fmla="val 7352"/>
+                  </a:avLst>
+                </a:prstGeom>
+                <a:solidFill>
+                  <a:srgbClr val="FFFFFF"/>
+                </a:solidFill>
+                <a:ln w="12700">
+                  <a:solidFill>
+                    <a:srgbClr val="9AA0B4"/>
+                  </a:solidFill>
+                </a:ln>
+              </p:spPr>
+            </p:sp>
+            <p:sp>
+              <p:nvSpPr>
+                <p:cNvPr id="119" name="Tag"/>
+                <p:cNvSpPr/>
+                <p:nvPr/>
+              </p:nvSpPr>
+              <p:spPr>
+                <a:xfrm>
+                  <a:off x="7205000" y="4050000"/>
+                  <a:ext cx="280000" cy="70000"/>
+                </a:xfrm>
+                <a:prstGeom prst="roundRect">
+                  <a:avLst>
+                    <a:gd name="adj" fmla="val 50000"/>
+                  </a:avLst>
+                </a:prstGeom>
+                <a:solidFill>
+                  <a:srgbClr val="DB2777"/>
+                </a:solidFill>
+                <a:ln>
+                  <a:noFill/>
+                </a:ln>
+              </p:spPr>
+            </p:sp>
+            <p:sp>
+              <p:nvSpPr>
+                <p:cNvPr id="120" name="Title line"/>
+                <p:cNvSpPr/>
+                <p:nvPr/>
+              </p:nvSpPr>
+              <p:spPr>
+                <a:xfrm>
+                  <a:off x="7205000" y="4190000"/>
+                  <a:ext cx="649600" cy="55000"/>
+                </a:xfrm>
+                <a:prstGeom prst="roundRect">
+                  <a:avLst>
+                    <a:gd name="adj" fmla="val 50000"/>
+                  </a:avLst>
+                </a:prstGeom>
+                <a:solidFill>
+                  <a:srgbClr val="484C5C"/>
+                </a:solidFill>
+                <a:ln>
+                  <a:noFill/>
+                </a:ln>
+              </p:spPr>
+            </p:sp>
+            <p:sp>
+              <p:nvSpPr>
+                <p:cNvPr id="121" name="Detail line"/>
+                <p:cNvSpPr/>
+                <p:nvPr/>
+              </p:nvSpPr>
+              <p:spPr>
+                <a:xfrm>
+                  <a:off x="7205000" y="4290000"/>
+                  <a:ext cx="492800" cy="45000"/>
+                </a:xfrm>
+                <a:prstGeom prst="roundRect">
+                  <a:avLst>
+                    <a:gd name="adj" fmla="val 50000"/>
+                  </a:avLst>
+                </a:prstGeom>
+                <a:solidFill>
+                  <a:srgbClr val="A3A8BC"/>
+                </a:solidFill>
+                <a:ln>
+                  <a:noFill/>
+                </a:ln>
+              </p:spPr>
+            </p:sp>
+            <p:sp>
+              <p:nvSpPr>
+                <p:cNvPr id="122" name="Checklist track"/>
+                <p:cNvSpPr/>
+                <p:nvPr/>
+              </p:nvSpPr>
+              <p:spPr>
+                <a:xfrm>
+                  <a:off x="7205000" y="4480000"/>
+                  <a:ext cx="420000" cy="45000"/>
+                </a:xfrm>
+                <a:prstGeom prst="roundRect">
+                  <a:avLst>
+                    <a:gd name="adj" fmla="val 50000"/>
+                  </a:avLst>
+                </a:prstGeom>
+                <a:solidFill>
+                  <a:srgbClr val="D0D3E0"/>
+                </a:solidFill>
+                <a:ln>
+                  <a:noFill/>
+                </a:ln>
+              </p:spPr>
+            </p:sp>
+            <p:sp>
+              <p:nvSpPr>
+                <p:cNvPr id="123" name="Assignee"/>
+                <p:cNvSpPr/>
+                <p:nvPr/>
+              </p:nvSpPr>
+              <p:spPr>
+                <a:xfrm>
+                  <a:off x="7760404" y="4420000"/>
+                  <a:ext cx="140000" cy="140000"/>
+                </a:xfrm>
+                <a:prstGeom prst="ellipse">
+                  <a:avLst/>
+                </a:prstGeom>
+                <a:solidFill>
+                  <a:srgbClr val="14B8A6"/>
+                </a:solidFill>
+                <a:ln>
+                  <a:noFill/>
+                </a:ln>
+              </p:spPr>
+            </p:sp>
+          </p:grpSp>
+          <p:grpSp>
+            <p:nvGrpSpPr>
+              <p:cNvPr id="131" name="Task card"/>
+              <p:cNvGrpSpPr/>
+              <p:nvPr/>
+            </p:nvGrpSpPr>
+            <p:grpSpPr>
+              <a:xfrm>
+                <a:off x="7115000" y="4740000"/>
+                <a:ext cx="875404" cy="680000"/>
+                <a:chOff x="7115000" y="4740000"/>
+                <a:chExt cx="875404" cy="680000"/>
+              </a:xfrm>
+            </p:grpSpPr>
+            <p:sp>
+              <p:nvSpPr>
+                <p:cNvPr id="125" name="Card"/>
+                <p:cNvSpPr/>
+                <p:nvPr/>
+              </p:nvSpPr>
+              <p:spPr>
+                <a:xfrm>
+                  <a:off x="7115000" y="4740000"/>
+                  <a:ext cx="875404" cy="680000"/>
+                </a:xfrm>
+                <a:prstGeom prst="roundRect">
+                  <a:avLst>
+                    <a:gd name="adj" fmla="val 7352"/>
+                  </a:avLst>
+                </a:prstGeom>
+                <a:solidFill>
+                  <a:srgbClr val="FFFFFF"/>
+                </a:solidFill>
+                <a:ln w="12700">
+                  <a:solidFill>
+                    <a:srgbClr val="9AA0B4"/>
+                  </a:solidFill>
+                </a:ln>
+              </p:spPr>
+            </p:sp>
+            <p:sp>
+              <p:nvSpPr>
+                <p:cNvPr id="126" name="Tag"/>
+                <p:cNvSpPr/>
+                <p:nvPr/>
+              </p:nvSpPr>
+              <p:spPr>
+                <a:xfrm>
+                  <a:off x="7205000" y="4840000"/>
+                  <a:ext cx="280000" cy="70000"/>
+                </a:xfrm>
+                <a:prstGeom prst="roundRect">
+                  <a:avLst>
+                    <a:gd name="adj" fmla="val 50000"/>
+                  </a:avLst>
+                </a:prstGeom>
+                <a:solidFill>
+                  <a:srgbClr val="4F46E5"/>
+                </a:solidFill>
+                <a:ln>
+                  <a:noFill/>
+                </a:ln>
+              </p:spPr>
+            </p:sp>
+            <p:sp>
+              <p:nvSpPr>
+                <p:cNvPr id="127" name="Title line"/>
+                <p:cNvSpPr/>
+                <p:nvPr/>
+              </p:nvSpPr>
+              <p:spPr>
+                <a:xfrm>
+                  <a:off x="7205000" y="4980000"/>
+                  <a:ext cx="492800" cy="55000"/>
+                </a:xfrm>
+                <a:prstGeom prst="roundRect">
+                  <a:avLst>
+                    <a:gd name="adj" fmla="val 50000"/>
+                  </a:avLst>
+                </a:prstGeom>
+                <a:solidFill>
+                  <a:srgbClr val="484C5C"/>
+                </a:solidFill>
+                <a:ln>
+                  <a:noFill/>
+                </a:ln>
+              </p:spPr>
+            </p:sp>
+            <p:sp>
+              <p:nvSpPr>
+                <p:cNvPr id="128" name="Detail line"/>
+                <p:cNvSpPr/>
+                <p:nvPr/>
+              </p:nvSpPr>
+              <p:spPr>
+                <a:xfrm>
+                  <a:off x="7205000" y="5080000"/>
+                  <a:ext cx="380800" cy="45000"/>
+                </a:xfrm>
+                <a:prstGeom prst="roundRect">
+                  <a:avLst>
+                    <a:gd name="adj" fmla="val 50000"/>
+                  </a:avLst>
+                </a:prstGeom>
+                <a:solidFill>
+                  <a:srgbClr val="A3A8BC"/>
+                </a:solidFill>
+                <a:ln>
+                  <a:noFill/>
+                </a:ln>
+              </p:spPr>
+            </p:sp>
+            <p:sp>
+              <p:nvSpPr>
+                <p:cNvPr id="129" name="Checklist track"/>
+                <p:cNvSpPr/>
+                <p:nvPr/>
+              </p:nvSpPr>
+              <p:spPr>
+                <a:xfrm>
+                  <a:off x="7205000" y="5270000"/>
+                  <a:ext cx="420000" cy="45000"/>
+                </a:xfrm>
+                <a:prstGeom prst="roundRect">
+                  <a:avLst>
+                    <a:gd name="adj" fmla="val 50000"/>
+                  </a:avLst>
+                </a:prstGeom>
+                <a:solidFill>
+                  <a:srgbClr val="D0D3E0"/>
+                </a:solidFill>
+                <a:ln>
+                  <a:noFill/>
+                </a:ln>
+              </p:spPr>
+            </p:sp>
+            <p:sp>
+              <p:nvSpPr>
+                <p:cNvPr id="130" name="Assignee"/>
+                <p:cNvSpPr/>
+                <p:nvPr/>
+              </p:nvSpPr>
+              <p:spPr>
+                <a:xfrm>
+                  <a:off x="7760404" y="5210000"/>
+                  <a:ext cx="140000" cy="140000"/>
+                </a:xfrm>
+                <a:prstGeom prst="ellipse">
+                  <a:avLst/>
+                </a:prstGeom>
+                <a:solidFill>
+                  <a:srgbClr val="A855F7"/>
+                </a:solidFill>
+                <a:ln>
+                  <a:noFill/>
+                </a:ln>
+              </p:spPr>
+            </p:sp>
+          </p:grpSp>
+        </p:grpSp>
+        <p:grpSp>
+          <p:nvGrpSpPr>
+            <p:cNvPr id="160" name="Column – In Progress"/>
+            <p:cNvGrpSpPr/>
+            <p:nvPr/>
+          </p:nvGrpSpPr>
+          <p:grpSpPr>
+            <a:xfrm>
+              <a:off x="8155404" y="1950000"/>
+              <a:ext cx="1025404" cy="3625000"/>
+              <a:chOff x="8155404" y="1950000"/>
+              <a:chExt cx="1025404" cy="3625000"/>
+            </a:xfrm>
+          </p:grpSpPr>
+          <p:sp>
+            <p:nvSpPr>
+              <p:cNvPr id="133" name="Column In Progress"/>
+              <p:cNvSpPr/>
+              <p:nvPr/>
+            </p:nvSpPr>
+            <p:spPr>
+              <a:xfrm>
+                <a:off x="8155404" y="1950000"/>
+                <a:ext cx="1025404" cy="3625000"/>
+              </a:xfrm>
+              <a:prstGeom prst="roundRect">
+                <a:avLst>
+                  <a:gd name="adj" fmla="val 5851"/>
+                </a:avLst>
+              </a:prstGeom>
+              <a:solidFill>
+                <a:srgbClr val="E4E7F2"/>
+              </a:solidFill>
+              <a:ln>
+                <a:noFill/>
+              </a:ln>
+            </p:spPr>
+          </p:sp>
+          <p:sp>
+            <p:nvSpPr>
+              <p:cNvPr id="134" name="Status dot"/>
+              <p:cNvSpPr/>
+              <p:nvPr/>
+            </p:nvSpPr>
+            <p:spPr>
+              <a:xfrm>
+                <a:off x="8255404" y="2095000"/>
+                <a:ext cx="90000" cy="90000"/>
+              </a:xfrm>
+              <a:prstGeom prst="ellipse">
+                <a:avLst/>
+              </a:prstGeom>
+              <a:solidFill>
+                <a:srgbClr val="4F46E5"/>
+              </a:solidFill>
+              <a:ln>
+                <a:noFill/>
+              </a:ln>
+            </p:spPr>
+          </p:sp>
+          <p:sp>
+            <p:nvSpPr>
+              <p:cNvPr id="135" name="Column label"/>
+              <p:cNvSpPr txBox="1"/>
+              <p:nvPr/>
+            </p:nvSpPr>
+            <p:spPr>
+              <a:xfrm>
+                <a:off x="8415404" y="2050000"/>
+                <a:ext cx="725404" cy="180000"/>
+              </a:xfrm>
+              <a:prstGeom prst="rect">
+                <a:avLst/>
+              </a:prstGeom>
+              <a:noFill/>
+              <a:ln>
+                <a:noFill/>
+              </a:ln>
+            </p:spPr>
+            <p:txBody>
+              <a:bodyPr wrap="none" lIns="0" tIns="0" rIns="0" bIns="0" rtlCol="0" anchor="ctr"/>
+              <a:lstStyle/>
+              <a:p>
+                <a:pPr algn="l"/>
+                <a:r>
+                  <a:rPr lang="en-US" sz="1000" b="1" dirty="0">
+                    <a:solidFill>
+                      <a:srgbClr val="1E202B"/>
+                    </a:solidFill>
+                    <a:latin typeface="Calibri"/>
+                    <a:cs typeface="Calibri"/>
+                  </a:rPr>
+                  <a:t>In Progress</a:t>
+                </a:r>
+              </a:p>
+            </p:txBody>
+          </p:sp>
+          <p:grpSp>
+            <p:nvGrpSpPr>
+              <p:cNvPr id="143" name="Task card"/>
+              <p:cNvGrpSpPr/>
+              <p:nvPr/>
+            </p:nvGrpSpPr>
+            <p:grpSpPr>
+              <a:xfrm>
+                <a:off x="8230404" y="2370000"/>
+                <a:ext cx="875404" cy="680000"/>
+                <a:chOff x="8230404" y="2370000"/>
+                <a:chExt cx="875404" cy="680000"/>
+              </a:xfrm>
+            </p:grpSpPr>
+            <p:sp>
+              <p:nvSpPr>
+                <p:cNvPr id="136" name="Card"/>
+                <p:cNvSpPr/>
+                <p:nvPr/>
+              </p:nvSpPr>
+              <p:spPr>
+                <a:xfrm>
+                  <a:off x="8230404" y="2370000"/>
+                  <a:ext cx="875404" cy="680000"/>
+                </a:xfrm>
+                <a:prstGeom prst="roundRect">
+                  <a:avLst>
+                    <a:gd name="adj" fmla="val 7352"/>
+                  </a:avLst>
+                </a:prstGeom>
+                <a:solidFill>
+                  <a:srgbClr val="FFFFFF"/>
+                </a:solidFill>
+                <a:ln w="12700">
+                  <a:solidFill>
+                    <a:srgbClr val="9AA0B4"/>
+                  </a:solidFill>
+                </a:ln>
+              </p:spPr>
+            </p:sp>
+            <p:sp>
+              <p:nvSpPr>
+                <p:cNvPr id="137" name="Tag"/>
+                <p:cNvSpPr/>
+                <p:nvPr/>
+              </p:nvSpPr>
+              <p:spPr>
+                <a:xfrm>
+                  <a:off x="8320404" y="2470000"/>
+                  <a:ext cx="280000" cy="70000"/>
+                </a:xfrm>
+                <a:prstGeom prst="roundRect">
+                  <a:avLst>
+                    <a:gd name="adj" fmla="val 50000"/>
+                  </a:avLst>
+                </a:prstGeom>
+                <a:solidFill>
+                  <a:srgbClr val="0D9488"/>
+                </a:solidFill>
+                <a:ln>
+                  <a:noFill/>
+                </a:ln>
+              </p:spPr>
+            </p:sp>
+            <p:sp>
+              <p:nvSpPr>
+                <p:cNvPr id="138" name="Title line"/>
+                <p:cNvSpPr/>
+                <p:nvPr/>
+              </p:nvSpPr>
+              <p:spPr>
+                <a:xfrm>
+                  <a:off x="8320404" y="2610000"/>
+                  <a:ext cx="672000" cy="55000"/>
+                </a:xfrm>
+                <a:prstGeom prst="roundRect">
+                  <a:avLst>
+                    <a:gd name="adj" fmla="val 50000"/>
+                  </a:avLst>
+                </a:prstGeom>
+                <a:solidFill>
+                  <a:srgbClr val="484C5C"/>
+                </a:solidFill>
+                <a:ln>
+                  <a:noFill/>
+                </a:ln>
+              </p:spPr>
+            </p:sp>
+            <p:sp>
+              <p:nvSpPr>
+                <p:cNvPr id="139" name="Detail line"/>
+                <p:cNvSpPr/>
+                <p:nvPr/>
+              </p:nvSpPr>
+              <p:spPr>
+                <a:xfrm>
+                  <a:off x="8320404" y="2710000"/>
+                  <a:ext cx="470400" cy="45000"/>
+                </a:xfrm>
+                <a:prstGeom prst="roundRect">
+                  <a:avLst>
+                    <a:gd name="adj" fmla="val 50000"/>
+                  </a:avLst>
+                </a:prstGeom>
+                <a:solidFill>
+                  <a:srgbClr val="A3A8BC"/>
+                </a:solidFill>
+                <a:ln>
+                  <a:noFill/>
+                </a:ln>
+              </p:spPr>
+            </p:sp>
+            <p:sp>
+              <p:nvSpPr>
+                <p:cNvPr id="140" name="Checklist track"/>
+                <p:cNvSpPr/>
+                <p:nvPr/>
+              </p:nvSpPr>
+              <p:spPr>
+                <a:xfrm>
+                  <a:off x="8320404" y="2900000"/>
+                  <a:ext cx="420000" cy="45000"/>
+                </a:xfrm>
+                <a:prstGeom prst="roundRect">
+                  <a:avLst>
+                    <a:gd name="adj" fmla="val 50000"/>
+                  </a:avLst>
+                </a:prstGeom>
+                <a:solidFill>
+                  <a:srgbClr val="D0D3E0"/>
+                </a:solidFill>
+                <a:ln>
+                  <a:noFill/>
+                </a:ln>
+              </p:spPr>
+            </p:sp>
+            <p:sp>
+              <p:nvSpPr>
+                <p:cNvPr id="141" name="Checklist progress"/>
+                <p:cNvSpPr/>
+                <p:nvPr/>
+              </p:nvSpPr>
+              <p:spPr>
+                <a:xfrm>
+                  <a:off x="8320404" y="2900000"/>
+                  <a:ext cx="147000" cy="45000"/>
+                </a:xfrm>
+                <a:prstGeom prst="roundRect">
+                  <a:avLst>
+                    <a:gd name="adj" fmla="val 50000"/>
+                  </a:avLst>
+                </a:prstGeom>
+                <a:solidFill>
+                  <a:srgbClr val="4F46E5"/>
+                </a:solidFill>
+                <a:ln>
+                  <a:noFill/>
+                </a:ln>
+              </p:spPr>
+            </p:sp>
+            <p:sp>
+              <p:nvSpPr>
+                <p:cNvPr id="142" name="Assignee"/>
+                <p:cNvSpPr/>
+                <p:nvPr/>
+              </p:nvSpPr>
+              <p:spPr>
+                <a:xfrm>
+                  <a:off x="8875807" y="2840000"/>
+                  <a:ext cx="140000" cy="140000"/>
+                </a:xfrm>
+                <a:prstGeom prst="ellipse">
+                  <a:avLst/>
+                </a:prstGeom>
+                <a:solidFill>
+                  <a:srgbClr val="6366F1"/>
+                </a:solidFill>
+                <a:ln>
+                  <a:noFill/>
+                </a:ln>
+              </p:spPr>
+            </p:sp>
+          </p:grpSp>
+          <p:grpSp>
+            <p:nvGrpSpPr>
+              <p:cNvPr id="151" name="Task card"/>
+              <p:cNvGrpSpPr/>
+              <p:nvPr/>
+            </p:nvGrpSpPr>
+            <p:grpSpPr>
+              <a:xfrm>
+                <a:off x="8230404" y="3160000"/>
+                <a:ext cx="875404" cy="680000"/>
+                <a:chOff x="8230404" y="3160000"/>
+                <a:chExt cx="875404" cy="680000"/>
+              </a:xfrm>
+            </p:grpSpPr>
+            <p:sp>
+              <p:nvSpPr>
+                <p:cNvPr id="144" name="Card"/>
+                <p:cNvSpPr/>
+                <p:nvPr/>
+              </p:nvSpPr>
+              <p:spPr>
+                <a:xfrm>
+                  <a:off x="8230404" y="3160000"/>
+                  <a:ext cx="875404" cy="680000"/>
+                </a:xfrm>
+                <a:prstGeom prst="roundRect">
+                  <a:avLst>
+                    <a:gd name="adj" fmla="val 7352"/>
+                  </a:avLst>
+                </a:prstGeom>
+                <a:solidFill>
+                  <a:srgbClr val="FFFFFF"/>
+                </a:solidFill>
+                <a:ln w="12700">
+                  <a:solidFill>
+                    <a:srgbClr val="9AA0B4"/>
+                  </a:solidFill>
+                </a:ln>
+              </p:spPr>
+            </p:sp>
+            <p:sp>
+              <p:nvSpPr>
+                <p:cNvPr id="145" name="Tag"/>
+                <p:cNvSpPr/>
+                <p:nvPr/>
+              </p:nvSpPr>
+              <p:spPr>
+                <a:xfrm>
+                  <a:off x="8320404" y="3260000"/>
+                  <a:ext cx="280000" cy="70000"/>
+                </a:xfrm>
+                <a:prstGeom prst="roundRect">
+                  <a:avLst>
+                    <a:gd name="adj" fmla="val 50000"/>
+                  </a:avLst>
+                </a:prstGeom>
+                <a:solidFill>
+                  <a:srgbClr val="4F46E5"/>
+                </a:solidFill>
+                <a:ln>
+                  <a:noFill/>
+                </a:ln>
+              </p:spPr>
+            </p:sp>
+            <p:sp>
+              <p:nvSpPr>
+                <p:cNvPr id="146" name="Title line"/>
+                <p:cNvSpPr/>
+                <p:nvPr/>
+              </p:nvSpPr>
+              <p:spPr>
+                <a:xfrm>
+                  <a:off x="8320404" y="3400000"/>
+                  <a:ext cx="582400" cy="55000"/>
+                </a:xfrm>
+                <a:prstGeom prst="roundRect">
+                  <a:avLst>
+                    <a:gd name="adj" fmla="val 50000"/>
+                  </a:avLst>
+                </a:prstGeom>
+                <a:solidFill>
+                  <a:srgbClr val="484C5C"/>
+                </a:solidFill>
+                <a:ln>
+                  <a:noFill/>
+                </a:ln>
+              </p:spPr>
+            </p:sp>
+            <p:sp>
+              <p:nvSpPr>
+                <p:cNvPr id="147" name="Detail line"/>
+                <p:cNvSpPr/>
+                <p:nvPr/>
+              </p:nvSpPr>
+              <p:spPr>
+                <a:xfrm>
+                  <a:off x="8320404" y="3500000"/>
+                  <a:ext cx="358400" cy="45000"/>
+                </a:xfrm>
+                <a:prstGeom prst="roundRect">
+                  <a:avLst>
+                    <a:gd name="adj" fmla="val 50000"/>
+                  </a:avLst>
+                </a:prstGeom>
+                <a:solidFill>
+                  <a:srgbClr val="A3A8BC"/>
+                </a:solidFill>
+                <a:ln>
+                  <a:noFill/>
+                </a:ln>
+              </p:spPr>
+            </p:sp>
+            <p:sp>
+              <p:nvSpPr>
+                <p:cNvPr id="148" name="Checklist track"/>
+                <p:cNvSpPr/>
+                <p:nvPr/>
+              </p:nvSpPr>
+              <p:spPr>
+                <a:xfrm>
+                  <a:off x="8320404" y="3690000"/>
+                  <a:ext cx="420000" cy="45000"/>
+                </a:xfrm>
+                <a:prstGeom prst="roundRect">
+                  <a:avLst>
+                    <a:gd name="adj" fmla="val 50000"/>
+                  </a:avLst>
+                </a:prstGeom>
+                <a:solidFill>
+                  <a:srgbClr val="D0D3E0"/>
+                </a:solidFill>
+                <a:ln>
+                  <a:noFill/>
+                </a:ln>
+              </p:spPr>
+            </p:sp>
+            <p:sp>
+              <p:nvSpPr>
+                <p:cNvPr id="149" name="Checklist progress"/>
+                <p:cNvSpPr/>
+                <p:nvPr/>
+              </p:nvSpPr>
+              <p:spPr>
+                <a:xfrm>
+                  <a:off x="8320404" y="3690000"/>
+                  <a:ext cx="252000" cy="45000"/>
+                </a:xfrm>
+                <a:prstGeom prst="roundRect">
+                  <a:avLst>
+                    <a:gd name="adj" fmla="val 50000"/>
+                  </a:avLst>
+                </a:prstGeom>
+                <a:solidFill>
+                  <a:srgbClr val="4F46E5"/>
+                </a:solidFill>
+                <a:ln>
+                  <a:noFill/>
+                </a:ln>
+              </p:spPr>
+            </p:sp>
+            <p:sp>
+              <p:nvSpPr>
+                <p:cNvPr id="150" name="Assignee"/>
+                <p:cNvSpPr/>
+                <p:nvPr/>
+              </p:nvSpPr>
+              <p:spPr>
+                <a:xfrm>
+                  <a:off x="8875807" y="3630000"/>
+                  <a:ext cx="140000" cy="140000"/>
+                </a:xfrm>
+                <a:prstGeom prst="ellipse">
+                  <a:avLst/>
+                </a:prstGeom>
+                <a:solidFill>
+                  <a:srgbClr val="EC4899"/>
+                </a:solidFill>
+                <a:ln>
+                  <a:noFill/>
+                </a:ln>
+              </p:spPr>
+            </p:sp>
+          </p:grpSp>
+          <p:grpSp>
+            <p:nvGrpSpPr>
+              <p:cNvPr id="159" name="Task card"/>
+              <p:cNvGrpSpPr/>
+              <p:nvPr/>
+            </p:nvGrpSpPr>
+            <p:grpSpPr>
+              <a:xfrm>
+                <a:off x="8230404" y="3950000"/>
+                <a:ext cx="875404" cy="680000"/>
+                <a:chOff x="8230404" y="3950000"/>
+                <a:chExt cx="875404" cy="680000"/>
+              </a:xfrm>
+            </p:grpSpPr>
+            <p:sp>
+              <p:nvSpPr>
+                <p:cNvPr id="152" name="Card"/>
+                <p:cNvSpPr/>
+                <p:nvPr/>
+              </p:nvSpPr>
+              <p:spPr>
+                <a:xfrm>
+                  <a:off x="8230404" y="3950000"/>
+                  <a:ext cx="875404" cy="680000"/>
+                </a:xfrm>
+                <a:prstGeom prst="roundRect">
+                  <a:avLst>
+                    <a:gd name="adj" fmla="val 7352"/>
+                  </a:avLst>
+                </a:prstGeom>
+                <a:solidFill>
+                  <a:srgbClr val="FFFFFF"/>
+                </a:solidFill>
+                <a:ln w="12700">
+                  <a:solidFill>
+                    <a:srgbClr val="9AA0B4"/>
+                  </a:solidFill>
+                </a:ln>
+              </p:spPr>
+            </p:sp>
+            <p:sp>
+              <p:nvSpPr>
+                <p:cNvPr id="153" name="Tag"/>
+                <p:cNvSpPr/>
+                <p:nvPr/>
+              </p:nvSpPr>
+              <p:spPr>
+                <a:xfrm>
+                  <a:off x="8320404" y="4050000"/>
+                  <a:ext cx="280000" cy="70000"/>
+                </a:xfrm>
+                <a:prstGeom prst="roundRect">
+                  <a:avLst>
+                    <a:gd name="adj" fmla="val 50000"/>
+                  </a:avLst>
+                </a:prstGeom>
+                <a:solidFill>
+                  <a:srgbClr val="DB2777"/>
+                </a:solidFill>
+                <a:ln>
+                  <a:noFill/>
+                </a:ln>
+              </p:spPr>
+            </p:sp>
+            <p:sp>
+              <p:nvSpPr>
+                <p:cNvPr id="154" name="Title line"/>
+                <p:cNvSpPr/>
+                <p:nvPr/>
+              </p:nvSpPr>
+              <p:spPr>
+                <a:xfrm>
+                  <a:off x="8320404" y="4190000"/>
+                  <a:ext cx="694400" cy="55000"/>
+                </a:xfrm>
+                <a:prstGeom prst="roundRect">
+                  <a:avLst>
+                    <a:gd name="adj" fmla="val 50000"/>
+                  </a:avLst>
+                </a:prstGeom>
+                <a:solidFill>
+                  <a:srgbClr val="484C5C"/>
+                </a:solidFill>
+                <a:ln>
+                  <a:noFill/>
+                </a:ln>
+              </p:spPr>
+            </p:sp>
+            <p:sp>
+              <p:nvSpPr>
+                <p:cNvPr id="155" name="Detail line"/>
+                <p:cNvSpPr/>
+                <p:nvPr/>
+              </p:nvSpPr>
+              <p:spPr>
+                <a:xfrm>
+                  <a:off x="8320404" y="4290000"/>
+                  <a:ext cx="425600" cy="45000"/>
+                </a:xfrm>
+                <a:prstGeom prst="roundRect">
+                  <a:avLst>
+                    <a:gd name="adj" fmla="val 50000"/>
+                  </a:avLst>
+                </a:prstGeom>
+                <a:solidFill>
+                  <a:srgbClr val="A3A8BC"/>
+                </a:solidFill>
+                <a:ln>
+                  <a:noFill/>
+                </a:ln>
+              </p:spPr>
+            </p:sp>
+            <p:sp>
+              <p:nvSpPr>
+                <p:cNvPr id="156" name="Checklist track"/>
+                <p:cNvSpPr/>
+                <p:nvPr/>
+              </p:nvSpPr>
+              <p:spPr>
+                <a:xfrm>
+                  <a:off x="8320404" y="4480000"/>
+                  <a:ext cx="420000" cy="45000"/>
+                </a:xfrm>
+                <a:prstGeom prst="roundRect">
+                  <a:avLst>
+                    <a:gd name="adj" fmla="val 50000"/>
+                  </a:avLst>
+                </a:prstGeom>
+                <a:solidFill>
+                  <a:srgbClr val="D0D3E0"/>
+                </a:solidFill>
+                <a:ln>
+                  <a:noFill/>
+                </a:ln>
+              </p:spPr>
+            </p:sp>
+            <p:sp>
+              <p:nvSpPr>
+                <p:cNvPr id="157" name="Checklist progress"/>
+                <p:cNvSpPr/>
+                <p:nvPr/>
+              </p:nvSpPr>
+              <p:spPr>
+                <a:xfrm>
+                  <a:off x="8320404" y="4480000"/>
+                  <a:ext cx="84000" cy="45000"/>
+                </a:xfrm>
+                <a:prstGeom prst="roundRect">
+                  <a:avLst>
+                    <a:gd name="adj" fmla="val 50000"/>
+                  </a:avLst>
+                </a:prstGeom>
+                <a:solidFill>
+                  <a:srgbClr val="4F46E5"/>
+                </a:solidFill>
+                <a:ln>
+                  <a:noFill/>
+                </a:ln>
+              </p:spPr>
+            </p:sp>
+            <p:sp>
+              <p:nvSpPr>
+                <p:cNvPr id="158" name="Assignee"/>
+                <p:cNvSpPr/>
+                <p:nvPr/>
+              </p:nvSpPr>
+              <p:spPr>
+                <a:xfrm>
+                  <a:off x="8875807" y="4420000"/>
+                  <a:ext cx="140000" cy="140000"/>
+                </a:xfrm>
+                <a:prstGeom prst="ellipse">
+                  <a:avLst/>
+                </a:prstGeom>
+                <a:solidFill>
+                  <a:srgbClr val="A855F7"/>
+                </a:solidFill>
+                <a:ln>
+                  <a:noFill/>
+                </a:ln>
+              </p:spPr>
+            </p:sp>
+          </p:grpSp>
+        </p:grpSp>
+        <p:grpSp>
+          <p:nvGrpSpPr>
+            <p:cNvPr id="180" name="Column – In Review"/>
+            <p:cNvGrpSpPr/>
+            <p:nvPr/>
+          </p:nvGrpSpPr>
+          <p:grpSpPr>
+            <a:xfrm>
+              <a:off x="9270808" y="1950000"/>
+              <a:ext cx="1025404" cy="3625000"/>
+              <a:chOff x="9270808" y="1950000"/>
+              <a:chExt cx="1025404" cy="3625000"/>
+            </a:xfrm>
+          </p:grpSpPr>
+          <p:sp>
+            <p:nvSpPr>
+              <p:cNvPr id="161" name="Column In Review"/>
+              <p:cNvSpPr/>
+              <p:nvPr/>
+            </p:nvSpPr>
+            <p:spPr>
+              <a:xfrm>
+                <a:off x="9270808" y="1950000"/>
+                <a:ext cx="1025404" cy="3625000"/>
+              </a:xfrm>
+              <a:prstGeom prst="roundRect">
+                <a:avLst>
+                  <a:gd name="adj" fmla="val 5851"/>
+                </a:avLst>
+              </a:prstGeom>
+              <a:solidFill>
+                <a:srgbClr val="E4E7F2"/>
+              </a:solidFill>
+              <a:ln>
+                <a:noFill/>
+              </a:ln>
+            </p:spPr>
+          </p:sp>
+          <p:sp>
+            <p:nvSpPr>
+              <p:cNvPr id="162" name="Status dot"/>
+              <p:cNvSpPr/>
+              <p:nvPr/>
+            </p:nvSpPr>
+            <p:spPr>
+              <a:xfrm>
+                <a:off x="9370808" y="2095000"/>
+                <a:ext cx="90000" cy="90000"/>
+              </a:xfrm>
+              <a:prstGeom prst="ellipse">
+                <a:avLst/>
+              </a:prstGeom>
+              <a:solidFill>
+                <a:srgbClr val="F59E0B"/>
+              </a:solidFill>
+              <a:ln>
+                <a:noFill/>
+              </a:ln>
+            </p:spPr>
+          </p:sp>
+          <p:sp>
+            <p:nvSpPr>
+              <p:cNvPr id="163" name="Column label"/>
+              <p:cNvSpPr txBox="1"/>
+              <p:nvPr/>
+            </p:nvSpPr>
+            <p:spPr>
+              <a:xfrm>
+                <a:off x="9530808" y="2050000"/>
+                <a:ext cx="725404" cy="180000"/>
+              </a:xfrm>
+              <a:prstGeom prst="rect">
+                <a:avLst/>
+              </a:prstGeom>
+              <a:noFill/>
+              <a:ln>
+                <a:noFill/>
+              </a:ln>
+            </p:spPr>
+            <p:txBody>
+              <a:bodyPr wrap="none" lIns="0" tIns="0" rIns="0" bIns="0" rtlCol="0" anchor="ctr"/>
+              <a:lstStyle/>
+              <a:p>
+                <a:pPr algn="l"/>
+                <a:r>
+                  <a:rPr lang="en-US" sz="1000" b="1" dirty="0">
+                    <a:solidFill>
+                      <a:srgbClr val="1E202B"/>
+                    </a:solidFill>
+                    <a:latin typeface="Calibri"/>
+                    <a:cs typeface="Calibri"/>
+                  </a:rPr>
+                  <a:t>In Review</a:t>
+                </a:r>
+              </a:p>
+            </p:txBody>
+          </p:sp>
+          <p:grpSp>
+            <p:nvGrpSpPr>
+              <p:cNvPr id="179" name="Task card"/>
+              <p:cNvGrpSpPr/>
+              <p:nvPr/>
+            </p:nvGrpSpPr>
+            <p:grpSpPr>
+              <a:xfrm>
+                <a:off x="9345808" y="3160000"/>
+                <a:ext cx="875404" cy="680000"/>
+                <a:chOff x="9345808" y="3160000"/>
+                <a:chExt cx="875404" cy="680000"/>
+              </a:xfrm>
+            </p:grpSpPr>
+            <p:sp>
+              <p:nvSpPr>
+                <p:cNvPr id="172" name="Card"/>
+                <p:cNvSpPr/>
+                <p:nvPr/>
+              </p:nvSpPr>
+              <p:spPr>
+                <a:xfrm>
+                  <a:off x="9345808" y="3160000"/>
+                  <a:ext cx="875404" cy="680000"/>
+                </a:xfrm>
+                <a:prstGeom prst="roundRect">
+                  <a:avLst>
+                    <a:gd name="adj" fmla="val 7352"/>
+                  </a:avLst>
+                </a:prstGeom>
+                <a:solidFill>
+                  <a:srgbClr val="FFFFFF"/>
+                </a:solidFill>
+                <a:ln w="12700">
+                  <a:solidFill>
+                    <a:srgbClr val="9AA0B4"/>
+                  </a:solidFill>
+                </a:ln>
+              </p:spPr>
+            </p:sp>
+            <p:sp>
+              <p:nvSpPr>
+                <p:cNvPr id="173" name="Tag"/>
+                <p:cNvSpPr/>
+                <p:nvPr/>
+              </p:nvSpPr>
+              <p:spPr>
+                <a:xfrm>
+                  <a:off x="9435808" y="3260000"/>
+                  <a:ext cx="280000" cy="70000"/>
+                </a:xfrm>
+                <a:prstGeom prst="roundRect">
+                  <a:avLst>
+                    <a:gd name="adj" fmla="val 50000"/>
+                  </a:avLst>
+                </a:prstGeom>
+                <a:solidFill>
+                  <a:srgbClr val="DB2777"/>
+                </a:solidFill>
+                <a:ln>
+                  <a:noFill/>
+                </a:ln>
+              </p:spPr>
+            </p:sp>
+            <p:sp>
+              <p:nvSpPr>
+                <p:cNvPr id="174" name="Title line"/>
+                <p:cNvSpPr/>
+                <p:nvPr/>
+              </p:nvSpPr>
+              <p:spPr>
+                <a:xfrm>
+                  <a:off x="9435808" y="3400000"/>
+                  <a:ext cx="537600" cy="55000"/>
+                </a:xfrm>
+                <a:prstGeom prst="roundRect">
+                  <a:avLst>
+                    <a:gd name="adj" fmla="val 50000"/>
+                  </a:avLst>
+                </a:prstGeom>
+                <a:solidFill>
+                  <a:srgbClr val="484C5C"/>
+                </a:solidFill>
+                <a:ln>
+                  <a:noFill/>
+                </a:ln>
+              </p:spPr>
+            </p:sp>
+            <p:sp>
+              <p:nvSpPr>
+                <p:cNvPr id="175" name="Detail line"/>
+                <p:cNvSpPr/>
+                <p:nvPr/>
+              </p:nvSpPr>
+              <p:spPr>
+                <a:xfrm>
+                  <a:off x="9435808" y="3500000"/>
+                  <a:ext cx="448000" cy="45000"/>
+                </a:xfrm>
+                <a:prstGeom prst="roundRect">
+                  <a:avLst>
+                    <a:gd name="adj" fmla="val 50000"/>
+                  </a:avLst>
+                </a:prstGeom>
+                <a:solidFill>
+                  <a:srgbClr val="A3A8BC"/>
+                </a:solidFill>
+                <a:ln>
+                  <a:noFill/>
+                </a:ln>
+              </p:spPr>
+            </p:sp>
+            <p:sp>
+              <p:nvSpPr>
+                <p:cNvPr id="176" name="Checklist track"/>
+                <p:cNvSpPr/>
+                <p:nvPr/>
+              </p:nvSpPr>
+              <p:spPr>
+                <a:xfrm>
+                  <a:off x="9435808" y="3690000"/>
+                  <a:ext cx="420000" cy="45000"/>
+                </a:xfrm>
+                <a:prstGeom prst="roundRect">
+                  <a:avLst>
+                    <a:gd name="adj" fmla="val 50000"/>
+                  </a:avLst>
+                </a:prstGeom>
+                <a:solidFill>
+                  <a:srgbClr val="D0D3E0"/>
+                </a:solidFill>
+                <a:ln>
+                  <a:noFill/>
+                </a:ln>
+              </p:spPr>
+            </p:sp>
+            <p:sp>
+              <p:nvSpPr>
+                <p:cNvPr id="177" name="Checklist progress"/>
+                <p:cNvSpPr/>
+                <p:nvPr/>
+              </p:nvSpPr>
+              <p:spPr>
+                <a:xfrm>
+                  <a:off x="9435808" y="3690000"/>
+                  <a:ext cx="420000" cy="45000"/>
+                </a:xfrm>
+                <a:prstGeom prst="roundRect">
+                  <a:avLst>
+                    <a:gd name="adj" fmla="val 50000"/>
+                  </a:avLst>
+                </a:prstGeom>
+                <a:solidFill>
+                  <a:srgbClr val="22C55E"/>
+                </a:solidFill>
+                <a:ln>
+                  <a:noFill/>
+                </a:ln>
+              </p:spPr>
+            </p:sp>
+            <p:sp>
+              <p:nvSpPr>
+                <p:cNvPr id="178" name="Assignee"/>
+                <p:cNvSpPr/>
+                <p:nvPr/>
+              </p:nvSpPr>
+              <p:spPr>
+                <a:xfrm>
+                  <a:off x="9991211" y="3630000"/>
+                  <a:ext cx="140000" cy="140000"/>
+                </a:xfrm>
+                <a:prstGeom prst="ellipse">
+                  <a:avLst/>
+                </a:prstGeom>
+                <a:solidFill>
+                  <a:srgbClr val="6366F1"/>
+                </a:solidFill>
+                <a:ln>
+                  <a:noFill/>
+                </a:ln>
+              </p:spPr>
+            </p:sp>
+          </p:grpSp>
+        </p:grpSp>
+        <p:grpSp>
+          <p:nvGrpSpPr>
+            <p:cNvPr id="208" name="Column – Done"/>
+            <p:cNvGrpSpPr/>
+            <p:nvPr/>
+          </p:nvGrpSpPr>
+          <p:grpSpPr>
+            <a:xfrm>
+              <a:off x="10386211" y="1950000"/>
+              <a:ext cx="1025404" cy="3625000"/>
+              <a:chOff x="10386211" y="1950000"/>
+              <a:chExt cx="1025404" cy="3625000"/>
+            </a:xfrm>
+          </p:grpSpPr>
+          <p:sp>
+            <p:nvSpPr>
+              <p:cNvPr id="181" name="Column Done"/>
+              <p:cNvSpPr/>
+              <p:nvPr/>
+            </p:nvSpPr>
+            <p:spPr>
+              <a:xfrm>
+                <a:off x="10386211" y="1950000"/>
+                <a:ext cx="1025404" cy="3625000"/>
+              </a:xfrm>
+              <a:prstGeom prst="roundRect">
+                <a:avLst>
+                  <a:gd name="adj" fmla="val 5851"/>
+                </a:avLst>
+              </a:prstGeom>
+              <a:solidFill>
+                <a:srgbClr val="E4E7F2"/>
+              </a:solidFill>
+              <a:ln>
+                <a:noFill/>
+              </a:ln>
+            </p:spPr>
+          </p:sp>
+          <p:sp>
+            <p:nvSpPr>
+              <p:cNvPr id="182" name="Status dot"/>
+              <p:cNvSpPr/>
+              <p:nvPr/>
+            </p:nvSpPr>
+            <p:spPr>
+              <a:xfrm>
+                <a:off x="10486211" y="2095000"/>
+                <a:ext cx="90000" cy="90000"/>
+              </a:xfrm>
+              <a:prstGeom prst="ellipse">
+                <a:avLst/>
+              </a:prstGeom>
+              <a:solidFill>
+                <a:srgbClr val="22C55E"/>
+              </a:solidFill>
+              <a:ln>
+                <a:noFill/>
+              </a:ln>
+            </p:spPr>
+          </p:sp>
+          <p:sp>
+            <p:nvSpPr>
+              <p:cNvPr id="183" name="Column label"/>
+              <p:cNvSpPr txBox="1"/>
+              <p:nvPr/>
+            </p:nvSpPr>
+            <p:spPr>
+              <a:xfrm>
+                <a:off x="10646211" y="2050000"/>
+                <a:ext cx="725404" cy="180000"/>
+              </a:xfrm>
+              <a:prstGeom prst="rect">
+                <a:avLst/>
+              </a:prstGeom>
+              <a:noFill/>
+              <a:ln>
+                <a:noFill/>
+              </a:ln>
+            </p:spPr>
+            <p:txBody>
+              <a:bodyPr wrap="none" lIns="0" tIns="0" rIns="0" bIns="0" rtlCol="0" anchor="ctr"/>
+              <a:lstStyle/>
+              <a:p>
+                <a:pPr algn="l"/>
+                <a:r>
+                  <a:rPr lang="en-US" sz="1000" b="1" dirty="0">
+                    <a:solidFill>
+                      <a:srgbClr val="1E202B"/>
+                    </a:solidFill>
+                    <a:latin typeface="Calibri"/>
+                    <a:cs typeface="Calibri"/>
+                  </a:rPr>
+                  <a:t>Done</a:t>
+                </a:r>
+              </a:p>
+            </p:txBody>
+          </p:sp>
+          <p:grpSp>
+            <p:nvGrpSpPr>
+              <p:cNvPr id="191" name="Task card"/>
+              <p:cNvGrpSpPr/>
+              <p:nvPr/>
+            </p:nvGrpSpPr>
+            <p:grpSpPr>
+              <a:xfrm>
+                <a:off x="10461211" y="2370000"/>
+                <a:ext cx="875404" cy="680000"/>
+                <a:chOff x="10461211" y="2370000"/>
+                <a:chExt cx="875404" cy="680000"/>
+              </a:xfrm>
+            </p:grpSpPr>
+            <p:sp>
+              <p:nvSpPr>
+                <p:cNvPr id="184" name="Card"/>
+                <p:cNvSpPr/>
+                <p:nvPr/>
+              </p:nvSpPr>
+              <p:spPr>
+                <a:xfrm>
+                  <a:off x="10461211" y="2370000"/>
+                  <a:ext cx="875404" cy="680000"/>
+                </a:xfrm>
+                <a:prstGeom prst="roundRect">
+                  <a:avLst>
+                    <a:gd name="adj" fmla="val 7352"/>
+                  </a:avLst>
+                </a:prstGeom>
+                <a:solidFill>
+                  <a:srgbClr val="FFFFFF"/>
+                </a:solidFill>
+                <a:ln w="12700">
+                  <a:solidFill>
+                    <a:srgbClr val="9AA0B4"/>
+                  </a:solidFill>
+                </a:ln>
+              </p:spPr>
+            </p:sp>
+            <p:sp>
+              <p:nvSpPr>
+                <p:cNvPr id="185" name="Tag"/>
+                <p:cNvSpPr/>
+                <p:nvPr/>
+              </p:nvSpPr>
+              <p:spPr>
+                <a:xfrm>
+                  <a:off x="10551211" y="2470000"/>
+                  <a:ext cx="280000" cy="70000"/>
+                </a:xfrm>
+                <a:prstGeom prst="roundRect">
+                  <a:avLst>
+                    <a:gd name="adj" fmla="val 50000"/>
+                  </a:avLst>
+                </a:prstGeom>
+                <a:solidFill>
+                  <a:srgbClr val="0D9488"/>
+                </a:solidFill>
+                <a:ln>
+                  <a:noFill/>
+                </a:ln>
+              </p:spPr>
+            </p:sp>
+            <p:sp>
+              <p:nvSpPr>
+                <p:cNvPr id="186" name="Title line"/>
+                <p:cNvSpPr/>
+                <p:nvPr/>
+              </p:nvSpPr>
+              <p:spPr>
+                <a:xfrm>
+                  <a:off x="10551211" y="2610000"/>
+                  <a:ext cx="672000" cy="55000"/>
+                </a:xfrm>
+                <a:prstGeom prst="roundRect">
+                  <a:avLst>
+                    <a:gd name="adj" fmla="val 50000"/>
+                  </a:avLst>
+                </a:prstGeom>
+                <a:solidFill>
+                  <a:srgbClr val="484C5C"/>
+                </a:solidFill>
+                <a:ln>
+                  <a:noFill/>
+                </a:ln>
+              </p:spPr>
+            </p:sp>
+            <p:sp>
+              <p:nvSpPr>
+                <p:cNvPr id="187" name="Detail line"/>
+                <p:cNvSpPr/>
+                <p:nvPr/>
+              </p:nvSpPr>
+              <p:spPr>
+                <a:xfrm>
+                  <a:off x="10551211" y="2710000"/>
+                  <a:ext cx="336000" cy="45000"/>
+                </a:xfrm>
+                <a:prstGeom prst="roundRect">
+                  <a:avLst>
+                    <a:gd name="adj" fmla="val 50000"/>
+                  </a:avLst>
+                </a:prstGeom>
+                <a:solidFill>
+                  <a:srgbClr val="A3A8BC"/>
+                </a:solidFill>
+                <a:ln>
+                  <a:noFill/>
+                </a:ln>
+              </p:spPr>
+            </p:sp>
+            <p:sp>
+              <p:nvSpPr>
+                <p:cNvPr id="188" name="Checklist track"/>
+                <p:cNvSpPr/>
+                <p:nvPr/>
+              </p:nvSpPr>
+              <p:spPr>
+                <a:xfrm>
+                  <a:off x="10551211" y="2900000"/>
+                  <a:ext cx="420000" cy="45000"/>
+                </a:xfrm>
+                <a:prstGeom prst="roundRect">
+                  <a:avLst>
+                    <a:gd name="adj" fmla="val 50000"/>
+                  </a:avLst>
+                </a:prstGeom>
+                <a:solidFill>
+                  <a:srgbClr val="D0D3E0"/>
+                </a:solidFill>
+                <a:ln>
+                  <a:noFill/>
+                </a:ln>
+              </p:spPr>
+            </p:sp>
+            <p:sp>
+              <p:nvSpPr>
+                <p:cNvPr id="189" name="Checklist progress"/>
+                <p:cNvSpPr/>
+                <p:nvPr/>
+              </p:nvSpPr>
+              <p:spPr>
+                <a:xfrm>
+                  <a:off x="10551211" y="2900000"/>
+                  <a:ext cx="420000" cy="45000"/>
+                </a:xfrm>
+                <a:prstGeom prst="roundRect">
+                  <a:avLst>
+                    <a:gd name="adj" fmla="val 50000"/>
+                  </a:avLst>
+                </a:prstGeom>
+                <a:solidFill>
+                  <a:srgbClr val="22C55E"/>
+                </a:solidFill>
+                <a:ln>
+                  <a:noFill/>
+                </a:ln>
+              </p:spPr>
+            </p:sp>
+            <p:sp>
+              <p:nvSpPr>
+                <p:cNvPr id="190" name="Assignee"/>
+                <p:cNvSpPr/>
+                <p:nvPr/>
+              </p:nvSpPr>
+              <p:spPr>
+                <a:xfrm>
+                  <a:off x="11106615" y="2840000"/>
+                  <a:ext cx="140000" cy="140000"/>
+                </a:xfrm>
+                <a:prstGeom prst="ellipse">
+                  <a:avLst/>
+                </a:prstGeom>
+                <a:solidFill>
+                  <a:srgbClr val="A855F7"/>
+                </a:solidFill>
+                <a:ln>
+                  <a:noFill/>
+                </a:ln>
+              </p:spPr>
+            </p:sp>
+          </p:grpSp>
+          <p:grpSp>
+            <p:nvGrpSpPr>
+              <p:cNvPr id="199" name="Task card"/>
+              <p:cNvGrpSpPr/>
+              <p:nvPr/>
+            </p:nvGrpSpPr>
+            <p:grpSpPr>
+              <a:xfrm>
+                <a:off x="10461211" y="3160000"/>
+                <a:ext cx="875404" cy="680000"/>
+                <a:chOff x="10461211" y="3160000"/>
+                <a:chExt cx="875404" cy="680000"/>
+              </a:xfrm>
+            </p:grpSpPr>
+            <p:sp>
+              <p:nvSpPr>
+                <p:cNvPr id="192" name="Card"/>
+                <p:cNvSpPr/>
+                <p:nvPr/>
+              </p:nvSpPr>
+              <p:spPr>
+                <a:xfrm>
+                  <a:off x="10461211" y="3160000"/>
+                  <a:ext cx="875404" cy="680000"/>
+                </a:xfrm>
+                <a:prstGeom prst="roundRect">
+                  <a:avLst>
+                    <a:gd name="adj" fmla="val 7352"/>
+                  </a:avLst>
+                </a:prstGeom>
+                <a:solidFill>
+                  <a:srgbClr val="FFFFFF"/>
+                </a:solidFill>
+                <a:ln w="12700">
+                  <a:solidFill>
+                    <a:srgbClr val="9AA0B4"/>
+                  </a:solidFill>
+                </a:ln>
+              </p:spPr>
+            </p:sp>
+            <p:sp>
+              <p:nvSpPr>
+                <p:cNvPr id="193" name="Tag"/>
+                <p:cNvSpPr/>
+                <p:nvPr/>
+              </p:nvSpPr>
+              <p:spPr>
+                <a:xfrm>
+                  <a:off x="10551211" y="3260000"/>
+                  <a:ext cx="280000" cy="70000"/>
+                </a:xfrm>
+                <a:prstGeom prst="roundRect">
+                  <a:avLst>
+                    <a:gd name="adj" fmla="val 50000"/>
+                  </a:avLst>
+                </a:prstGeom>
+                <a:solidFill>
+                  <a:srgbClr val="4F46E5"/>
+                </a:solidFill>
+                <a:ln>
+                  <a:noFill/>
+                </a:ln>
+              </p:spPr>
+            </p:sp>
+            <p:sp>
+              <p:nvSpPr>
+                <p:cNvPr id="194" name="Title line"/>
+                <p:cNvSpPr/>
+                <p:nvPr/>
+              </p:nvSpPr>
+              <p:spPr>
+                <a:xfrm>
+                  <a:off x="10551211" y="3400000"/>
+                  <a:ext cx="560000" cy="55000"/>
+                </a:xfrm>
+                <a:prstGeom prst="roundRect">
+                  <a:avLst>
+                    <a:gd name="adj" fmla="val 50000"/>
+                  </a:avLst>
+                </a:prstGeom>
+                <a:solidFill>
+                  <a:srgbClr val="484C5C"/>
+                </a:solidFill>
+                <a:ln>
+                  <a:noFill/>
+                </a:ln>
+              </p:spPr>
+            </p:sp>
+            <p:sp>
+              <p:nvSpPr>
+                <p:cNvPr id="195" name="Detail line"/>
+                <p:cNvSpPr/>
+                <p:nvPr/>
+              </p:nvSpPr>
+              <p:spPr>
+                <a:xfrm>
+                  <a:off x="10551211" y="3500000"/>
+                  <a:ext cx="470400" cy="45000"/>
+                </a:xfrm>
+                <a:prstGeom prst="roundRect">
+                  <a:avLst>
+                    <a:gd name="adj" fmla="val 50000"/>
+                  </a:avLst>
+                </a:prstGeom>
+                <a:solidFill>
+                  <a:srgbClr val="A3A8BC"/>
+                </a:solidFill>
+                <a:ln>
+                  <a:noFill/>
+                </a:ln>
+              </p:spPr>
+            </p:sp>
+            <p:sp>
+              <p:nvSpPr>
+                <p:cNvPr id="196" name="Checklist track"/>
+                <p:cNvSpPr/>
+                <p:nvPr/>
+              </p:nvSpPr>
+              <p:spPr>
+                <a:xfrm>
+                  <a:off x="10551211" y="3690000"/>
+                  <a:ext cx="420000" cy="45000"/>
+                </a:xfrm>
+                <a:prstGeom prst="roundRect">
+                  <a:avLst>
+                    <a:gd name="adj" fmla="val 50000"/>
+                  </a:avLst>
+                </a:prstGeom>
+                <a:solidFill>
+                  <a:srgbClr val="D0D3E0"/>
+                </a:solidFill>
+                <a:ln>
+                  <a:noFill/>
+                </a:ln>
+              </p:spPr>
+            </p:sp>
+            <p:sp>
+              <p:nvSpPr>
+                <p:cNvPr id="197" name="Checklist progress"/>
+                <p:cNvSpPr/>
+                <p:nvPr/>
+              </p:nvSpPr>
+              <p:spPr>
+                <a:xfrm>
+                  <a:off x="10551211" y="3690000"/>
+                  <a:ext cx="420000" cy="45000"/>
+                </a:xfrm>
+                <a:prstGeom prst="roundRect">
+                  <a:avLst>
+                    <a:gd name="adj" fmla="val 50000"/>
+                  </a:avLst>
+                </a:prstGeom>
+                <a:solidFill>
+                  <a:srgbClr val="22C55E"/>
+                </a:solidFill>
+                <a:ln>
+                  <a:noFill/>
+                </a:ln>
+              </p:spPr>
+            </p:sp>
+            <p:sp>
+              <p:nvSpPr>
+                <p:cNvPr id="198" name="Assignee"/>
+                <p:cNvSpPr/>
+                <p:nvPr/>
+              </p:nvSpPr>
+              <p:spPr>
+                <a:xfrm>
+                  <a:off x="11106615" y="3630000"/>
+                  <a:ext cx="140000" cy="140000"/>
+                </a:xfrm>
+                <a:prstGeom prst="ellipse">
+                  <a:avLst/>
+                </a:prstGeom>
+                <a:solidFill>
+                  <a:srgbClr val="EC4899"/>
+                </a:solidFill>
+                <a:ln>
+                  <a:noFill/>
+                </a:ln>
+              </p:spPr>
+            </p:sp>
+          </p:grpSp>
+          <p:grpSp>
+            <p:nvGrpSpPr>
+              <p:cNvPr id="207" name="Task card"/>
+              <p:cNvGrpSpPr/>
+              <p:nvPr/>
+            </p:nvGrpSpPr>
+            <p:grpSpPr>
+              <a:xfrm>
+                <a:off x="10461211" y="3950000"/>
+                <a:ext cx="875404" cy="680000"/>
+                <a:chOff x="10461211" y="3950000"/>
+                <a:chExt cx="875404" cy="680000"/>
+              </a:xfrm>
+            </p:grpSpPr>
+            <p:sp>
+              <p:nvSpPr>
+                <p:cNvPr id="200" name="Card"/>
+                <p:cNvSpPr/>
+                <p:nvPr/>
+              </p:nvSpPr>
+              <p:spPr>
+                <a:xfrm>
+                  <a:off x="10461211" y="3950000"/>
+                  <a:ext cx="875404" cy="680000"/>
+                </a:xfrm>
+                <a:prstGeom prst="roundRect">
+                  <a:avLst>
+                    <a:gd name="adj" fmla="val 7352"/>
+                  </a:avLst>
+                </a:prstGeom>
+                <a:solidFill>
+                  <a:srgbClr val="FFFFFF"/>
+                </a:solidFill>
+                <a:ln w="12700">
+                  <a:solidFill>
+                    <a:srgbClr val="9AA0B4"/>
+                  </a:solidFill>
+                </a:ln>
+              </p:spPr>
+            </p:sp>
+            <p:sp>
+              <p:nvSpPr>
+                <p:cNvPr id="201" name="Tag"/>
+                <p:cNvSpPr/>
+                <p:nvPr/>
+              </p:nvSpPr>
+              <p:spPr>
+                <a:xfrm>
+                  <a:off x="10551211" y="4050000"/>
+                  <a:ext cx="280000" cy="70000"/>
+                </a:xfrm>
+                <a:prstGeom prst="roundRect">
+                  <a:avLst>
+                    <a:gd name="adj" fmla="val 50000"/>
+                  </a:avLst>
+                </a:prstGeom>
+                <a:solidFill>
+                  <a:srgbClr val="DB2777"/>
+                </a:solidFill>
+                <a:ln>
+                  <a:noFill/>
+                </a:ln>
+              </p:spPr>
+            </p:sp>
+            <p:sp>
+              <p:nvSpPr>
+                <p:cNvPr id="202" name="Title line"/>
+                <p:cNvSpPr/>
+                <p:nvPr/>
+              </p:nvSpPr>
+              <p:spPr>
+                <a:xfrm>
+                  <a:off x="10551211" y="4190000"/>
+                  <a:ext cx="627200" cy="55000"/>
+                </a:xfrm>
+                <a:prstGeom prst="roundRect">
+                  <a:avLst>
+                    <a:gd name="adj" fmla="val 50000"/>
+                  </a:avLst>
+                </a:prstGeom>
+                <a:solidFill>
+                  <a:srgbClr val="484C5C"/>
+                </a:solidFill>
+                <a:ln>
+                  <a:noFill/>
+                </a:ln>
+              </p:spPr>
+            </p:sp>
+            <p:sp>
+              <p:nvSpPr>
+                <p:cNvPr id="203" name="Detail line"/>
+                <p:cNvSpPr/>
+                <p:nvPr/>
+              </p:nvSpPr>
+              <p:spPr>
+                <a:xfrm>
+                  <a:off x="10551211" y="4290000"/>
+                  <a:ext cx="380800" cy="45000"/>
+                </a:xfrm>
+                <a:prstGeom prst="roundRect">
+                  <a:avLst>
+                    <a:gd name="adj" fmla="val 50000"/>
+                  </a:avLst>
+                </a:prstGeom>
+                <a:solidFill>
+                  <a:srgbClr val="A3A8BC"/>
+                </a:solidFill>
+                <a:ln>
+                  <a:noFill/>
+                </a:ln>
+              </p:spPr>
+            </p:sp>
+            <p:sp>
+              <p:nvSpPr>
+                <p:cNvPr id="204" name="Checklist track"/>
+                <p:cNvSpPr/>
+                <p:nvPr/>
+              </p:nvSpPr>
+              <p:spPr>
+                <a:xfrm>
+                  <a:off x="10551211" y="4480000"/>
+                  <a:ext cx="420000" cy="45000"/>
+                </a:xfrm>
+                <a:prstGeom prst="roundRect">
+                  <a:avLst>
+                    <a:gd name="adj" fmla="val 50000"/>
+                  </a:avLst>
+                </a:prstGeom>
+                <a:solidFill>
+                  <a:srgbClr val="D0D3E0"/>
+                </a:solidFill>
+                <a:ln>
+                  <a:noFill/>
+                </a:ln>
+              </p:spPr>
+            </p:sp>
+            <p:sp>
+              <p:nvSpPr>
+                <p:cNvPr id="205" name="Checklist progress"/>
+                <p:cNvSpPr/>
+                <p:nvPr/>
+              </p:nvSpPr>
+              <p:spPr>
+                <a:xfrm>
+                  <a:off x="10551211" y="4480000"/>
+                  <a:ext cx="420000" cy="45000"/>
+                </a:xfrm>
+                <a:prstGeom prst="roundRect">
+                  <a:avLst>
+                    <a:gd name="adj" fmla="val 50000"/>
+                  </a:avLst>
+                </a:prstGeom>
+                <a:solidFill>
+                  <a:srgbClr val="22C55E"/>
+                </a:solidFill>
+                <a:ln>
+                  <a:noFill/>
+                </a:ln>
+              </p:spPr>
+            </p:sp>
+            <p:sp>
+              <p:nvSpPr>
+                <p:cNvPr id="206" name="Assignee"/>
+                <p:cNvSpPr/>
+                <p:nvPr/>
+              </p:nvSpPr>
+              <p:spPr>
+                <a:xfrm>
+                  <a:off x="11106615" y="4420000"/>
+                  <a:ext cx="140000" cy="140000"/>
+                </a:xfrm>
+                <a:prstGeom prst="ellipse">
+                  <a:avLst/>
+                </a:prstGeom>
+                <a:solidFill>
+                  <a:srgbClr val="14B8A6"/>
+                </a:solidFill>
+                <a:ln>
+                  <a:noFill/>
+                </a:ln>
+              </p:spPr>
+            </p:sp>
+          </p:grpSp>
+        </p:grpSp>
+        <p:grpSp>
+          <p:nvGrpSpPr>
+            <p:cNvPr id="171" name="Card (being dragged)"/>
+            <p:cNvGrpSpPr/>
+            <p:nvPr/>
+          </p:nvGrpSpPr>
+          <p:grpSpPr>
+            <a:xfrm rot="120000">
+              <a:off x="9375807" y="2350000"/>
+              <a:ext cx="875404" cy="680000"/>
+              <a:chOff x="9375807" y="2350000"/>
+              <a:chExt cx="875404" cy="680000"/>
+            </a:xfrm>
+          </p:grpSpPr>
+          <p:sp>
+            <p:nvSpPr>
+              <p:cNvPr id="164" name="Card"/>
+              <p:cNvSpPr/>
+              <p:nvPr/>
+            </p:nvSpPr>
+            <p:spPr>
+              <a:xfrm>
+                <a:off x="9375807" y="2350000"/>
+                <a:ext cx="875404" cy="680000"/>
+              </a:xfrm>
+              <a:prstGeom prst="roundRect">
+                <a:avLst>
+                  <a:gd name="adj" fmla="val 7352"/>
+                </a:avLst>
+              </a:prstGeom>
+              <a:solidFill>
+                <a:srgbClr val="EEF0FF"/>
+              </a:solidFill>
+              <a:ln w="25400">
+                <a:solidFill>
+                  <a:srgbClr val="4F46E5"/>
+                </a:solidFill>
+              </a:ln>
+              <a:effectLst>
+                <a:outerShdw blurRad="190500" dist="63500" dir="5400000" algn="t" rotWithShape="0">
+                  <a:srgbClr val="1E202B">
+                    <a:alpha val="30000"/>
+                  </a:srgbClr>
+                </a:outerShdw>
+              </a:effectLst>
+            </p:spPr>
+          </p:sp>
+          <p:sp>
+            <p:nvSpPr>
+              <p:cNvPr id="165" name="Tag"/>
+              <p:cNvSpPr/>
+              <p:nvPr/>
+            </p:nvSpPr>
+            <p:spPr>
+              <a:xfrm>
+                <a:off x="9465807" y="2450000"/>
+                <a:ext cx="280000" cy="70000"/>
+              </a:xfrm>
+              <a:prstGeom prst="roundRect">
+                <a:avLst>
+                  <a:gd name="adj" fmla="val 50000"/>
+                </a:avLst>
+              </a:prstGeom>
+              <a:solidFill>
+                <a:srgbClr val="4F46E5"/>
+              </a:solidFill>
+              <a:ln>
+                <a:noFill/>
+              </a:ln>
+            </p:spPr>
+          </p:sp>
+          <p:sp>
+            <p:nvSpPr>
+              <p:cNvPr id="166" name="Title line"/>
+              <p:cNvSpPr/>
+              <p:nvPr/>
+            </p:nvSpPr>
+            <p:spPr>
+              <a:xfrm>
+                <a:off x="9465807" y="2590000"/>
+                <a:ext cx="649600" cy="55000"/>
+              </a:xfrm>
+              <a:prstGeom prst="roundRect">
+                <a:avLst>
+                  <a:gd name="adj" fmla="val 50000"/>
+                </a:avLst>
+              </a:prstGeom>
+              <a:solidFill>
+                <a:srgbClr val="484C5C"/>
+              </a:solidFill>
+              <a:ln>
+                <a:noFill/>
+              </a:ln>
+            </p:spPr>
+          </p:sp>
+          <p:sp>
+            <p:nvSpPr>
+              <p:cNvPr id="167" name="Detail line"/>
+              <p:cNvSpPr/>
+              <p:nvPr/>
+            </p:nvSpPr>
+            <p:spPr>
+              <a:xfrm>
+                <a:off x="9465807" y="2690000"/>
+                <a:ext cx="403200" cy="45000"/>
+              </a:xfrm>
+              <a:prstGeom prst="roundRect">
+                <a:avLst>
+                  <a:gd name="adj" fmla="val 50000"/>
+                </a:avLst>
+              </a:prstGeom>
+              <a:solidFill>
+                <a:srgbClr val="A3A8BC"/>
+              </a:solidFill>
+              <a:ln>
+                <a:noFill/>
+              </a:ln>
+            </p:spPr>
+          </p:sp>
+          <p:sp>
+            <p:nvSpPr>
+              <p:cNvPr id="168" name="Checklist track"/>
+              <p:cNvSpPr/>
+              <p:nvPr/>
+            </p:nvSpPr>
+            <p:spPr>
+              <a:xfrm>
+                <a:off x="9465807" y="2880000"/>
+                <a:ext cx="420000" cy="45000"/>
+              </a:xfrm>
+              <a:prstGeom prst="roundRect">
+                <a:avLst>
+                  <a:gd name="adj" fmla="val 50000"/>
+                </a:avLst>
+              </a:prstGeom>
+              <a:solidFill>
+                <a:srgbClr val="D0D3E0"/>
+              </a:solidFill>
+              <a:ln>
+                <a:noFill/>
+              </a:ln>
+            </p:spPr>
+          </p:sp>
+          <p:sp>
+            <p:nvSpPr>
+              <p:cNvPr id="169" name="Checklist progress"/>
+              <p:cNvSpPr/>
+              <p:nvPr/>
+            </p:nvSpPr>
+            <p:spPr>
+              <a:xfrm>
+                <a:off x="9465807" y="2880000"/>
+                <a:ext cx="357000" cy="45000"/>
+              </a:xfrm>
+              <a:prstGeom prst="roundRect">
+                <a:avLst>
+                  <a:gd name="adj" fmla="val 50000"/>
+                </a:avLst>
+              </a:prstGeom>
+              <a:solidFill>
+                <a:srgbClr val="4F46E5"/>
+              </a:solidFill>
+              <a:ln>
+                <a:noFill/>
+              </a:ln>
+            </p:spPr>
+          </p:sp>
+          <p:sp>
+            <p:nvSpPr>
+              <p:cNvPr id="170" name="Assignee"/>
+              <p:cNvSpPr/>
+              <p:nvPr/>
+            </p:nvSpPr>
+            <p:spPr>
+              <a:xfrm>
+                <a:off x="10021211" y="2820000"/>
+                <a:ext cx="140000" cy="140000"/>
+              </a:xfrm>
+              <a:prstGeom prst="ellipse">
+                <a:avLst/>
+              </a:prstGeom>
+              <a:solidFill>
+                <a:srgbClr val="14B8A6"/>
+              </a:solidFill>
+              <a:ln>
+                <a:noFill/>
+              </a:ln>
+            </p:spPr>
+          </p:sp>
+        </p:grpSp>
+      </p:grpSp>
       <p:sp>
         <p:nvSpPr>
           <p:cNvPr id="14" name="Text 12"/>
@@ -2745,8 +5193,8 @@
         </p:nvSpPr>
         <p:spPr>
           <a:xfrm>
-            <a:off x="640080" y="1554480"/>
-            <a:ext cx="6400800" cy="274320"/>
+            <a:off x="640080" y="1350000"/>
+            <a:ext cx="5900000" cy="340000"/>
           </a:xfrm>
           <a:prstGeom prst="rect">
             <a:avLst/>
@@ -2762,9 +5210,9 @@
               <a:buNone/>
             </a:pPr>
             <a:r>
-              <a:rPr lang="en-US" sz="1100" spc="100" kern="0" dirty="0">
-                <a:solidFill>
-                  <a:srgbClr val="AEB2E8"/>
+              <a:rPr lang="en-US" sz="1400" spc="150" kern="0" dirty="0">
+                <a:solidFill>
+                  <a:srgbClr val="4F46E5"/>
                 </a:solidFill>
                 <a:latin typeface="Calibri" pitchFamily="34" charset="0"/>
                 <a:ea typeface="Calibri" pitchFamily="34" charset="-122"/>
@@ -2772,7 +5220,7 @@
               </a:rPr>
               <a:t>END-OF-YEAR INTERNSHIP REPORT</a:t>
             </a:r>
-            <a:endParaRPr lang="en-US" sz="1100" dirty="0"/>
+            <a:endParaRPr lang="en-US" sz="1400" dirty="0"/>
           </a:p>
         </p:txBody>
       </p:sp>
@@ -2784,8 +5232,8 @@
         </p:nvSpPr>
         <p:spPr>
           <a:xfrm>
-            <a:off x="640080" y="1874520"/>
-            <a:ext cx="6858000" cy="1188720"/>
+            <a:off x="640080" y="1620000"/>
+            <a:ext cx="5900000" cy="1050000"/>
           </a:xfrm>
           <a:prstGeom prst="rect">
             <a:avLst/>
@@ -2803,7 +5251,7 @@
             <a:r>
               <a:rPr lang="en-US" sz="6600" b="1" dirty="0">
                 <a:solidFill>
-                  <a:srgbClr val="FFFFFF"/>
+                  <a:srgbClr val="1E202B"/>
                 </a:solidFill>
                 <a:latin typeface="Cambria" pitchFamily="34" charset="0"/>
                 <a:ea typeface="Cambria" pitchFamily="34" charset="-122"/>
@@ -2823,8 +5271,8 @@
         </p:nvSpPr>
         <p:spPr>
           <a:xfrm>
-            <a:off x="640080" y="2971800"/>
-            <a:ext cx="6583680" cy="822960"/>
+            <a:off x="640080" y="2720000"/>
+            <a:ext cx="5900000" cy="850000"/>
           </a:xfrm>
           <a:prstGeom prst="rect">
             <a:avLst/>
@@ -2840,9 +5288,9 @@
               <a:buNone/>
             </a:pPr>
             <a:r>
-              <a:rPr lang="en-US" sz="1600" dirty="0">
-                <a:solidFill>
-                  <a:srgbClr val="D6D8F5"/>
+              <a:rPr lang="en-US" sz="1800" dirty="0">
+                <a:solidFill>
+                  <a:srgbClr val="484C5C"/>
                 </a:solidFill>
                 <a:latin typeface="Calibri" pitchFamily="34" charset="0"/>
                 <a:ea typeface="Calibri" pitchFamily="34" charset="-122"/>
@@ -2850,16 +5298,16 @@
               </a:rPr>
               <a:t>Design and development of a collaborative project</a:t>
             </a:r>
-            <a:endParaRPr lang="en-US" sz="1600" dirty="0"/>
+            <a:endParaRPr lang="en-US" sz="1800" dirty="0"/>
           </a:p>
           <a:p>
             <a:pPr indent="0" marL="0">
               <a:buNone/>
             </a:pPr>
             <a:r>
-              <a:rPr lang="en-US" sz="1600" dirty="0">
-                <a:solidFill>
-                  <a:srgbClr val="D6D8F5"/>
+              <a:rPr lang="en-US" sz="1800" dirty="0">
+                <a:solidFill>
+                  <a:srgbClr val="484C5C"/>
                 </a:solidFill>
                 <a:latin typeface="Calibri" pitchFamily="34" charset="0"/>
                 <a:ea typeface="Calibri" pitchFamily="34" charset="-122"/>
@@ -2867,7 +5315,7 @@
               </a:rPr>
               <a:t>and task management platform</a:t>
             </a:r>
-            <a:endParaRPr lang="en-US" sz="1600" dirty="0"/>
+            <a:endParaRPr lang="en-US" sz="1800" dirty="0"/>
           </a:p>
         </p:txBody>
       </p:sp>
@@ -2879,8 +5327,8 @@
         </p:nvSpPr>
         <p:spPr>
           <a:xfrm>
-            <a:off x="640080" y="4709160"/>
-            <a:ext cx="1920240" cy="274320"/>
+            <a:off x="640080" y="3875000"/>
+            <a:ext cx="5900000" cy="240000"/>
           </a:xfrm>
           <a:prstGeom prst="rect">
             <a:avLst/>
@@ -2896,9 +5344,9 @@
               <a:buNone/>
             </a:pPr>
             <a:r>
-              <a:rPr lang="en-US" sz="950" dirty="0">
-                <a:solidFill>
-                  <a:srgbClr val="9DA1D6"/>
+              <a:rPr lang="en-US" sz="1300" dirty="0">
+                <a:solidFill>
+                  <a:srgbClr val="484C5C"/>
                 </a:solidFill>
                 <a:latin typeface="Calibri" pitchFamily="34" charset="0"/>
                 <a:ea typeface="Calibri" pitchFamily="34" charset="-122"/>
@@ -2906,7 +5354,7 @@
               </a:rPr>
               <a:t>Prepared by</a:t>
             </a:r>
-            <a:endParaRPr lang="en-US" sz="950" dirty="0"/>
+            <a:endParaRPr lang="en-US" sz="1300" dirty="0"/>
           </a:p>
         </p:txBody>
       </p:sp>
@@ -2918,8 +5366,8 @@
         </p:nvSpPr>
         <p:spPr>
           <a:xfrm>
-            <a:off x="2606040" y="4709160"/>
-            <a:ext cx="5486400" cy="274320"/>
+            <a:off x="640080" y="4115000"/>
+            <a:ext cx="5900000" cy="320000"/>
           </a:xfrm>
           <a:prstGeom prst="rect">
             <a:avLst/>
@@ -2935,9 +5383,9 @@
               <a:buNone/>
             </a:pPr>
             <a:r>
-              <a:rPr lang="en-US" sz="1250" dirty="0">
-                <a:solidFill>
-                  <a:srgbClr val="DEE0F2"/>
+              <a:rPr lang="en-US" sz="1600" dirty="0">
+                <a:solidFill>
+                  <a:srgbClr val="1E202B"/>
                 </a:solidFill>
                 <a:latin typeface="Calibri" pitchFamily="34" charset="0"/>
                 <a:ea typeface="Calibri" pitchFamily="34" charset="-122"/>
@@ -2945,7 +5393,7 @@
               </a:rPr>
               <a:t>Adem Ouerhani</a:t>
             </a:r>
-            <a:endParaRPr lang="en-US" sz="1250" dirty="0"/>
+            <a:endParaRPr lang="en-US" sz="1600" dirty="0"/>
           </a:p>
         </p:txBody>
       </p:sp>
@@ -2957,8 +5405,8 @@
         </p:nvSpPr>
         <p:spPr>
           <a:xfrm>
-            <a:off x="640080" y="5074920"/>
-            <a:ext cx="1920240" cy="274320"/>
+            <a:off x="640080" y="4515000"/>
+            <a:ext cx="5900000" cy="240000"/>
           </a:xfrm>
           <a:prstGeom prst="rect">
             <a:avLst/>
@@ -2974,9 +5422,9 @@
               <a:buNone/>
             </a:pPr>
             <a:r>
-              <a:rPr lang="en-US" sz="950" dirty="0">
-                <a:solidFill>
-                  <a:srgbClr val="9DA1D6"/>
+              <a:rPr lang="en-US" sz="1300" dirty="0">
+                <a:solidFill>
+                  <a:srgbClr val="484C5C"/>
                 </a:solidFill>
                 <a:latin typeface="Calibri" pitchFamily="34" charset="0"/>
                 <a:ea typeface="Calibri" pitchFamily="34" charset="-122"/>
@@ -2984,7 +5432,7 @@
               </a:rPr>
               <a:t>Professional supervisor</a:t>
             </a:r>
-            <a:endParaRPr lang="en-US" sz="950" dirty="0"/>
+            <a:endParaRPr lang="en-US" sz="1300" dirty="0"/>
           </a:p>
         </p:txBody>
       </p:sp>
@@ -2996,8 +5444,8 @@
         </p:nvSpPr>
         <p:spPr>
           <a:xfrm>
-            <a:off x="2606040" y="5074920"/>
-            <a:ext cx="5486400" cy="274320"/>
+            <a:off x="640080" y="4755000"/>
+            <a:ext cx="5900000" cy="320000"/>
           </a:xfrm>
           <a:prstGeom prst="rect">
             <a:avLst/>
@@ -3013,9 +5461,9 @@
               <a:buNone/>
             </a:pPr>
             <a:r>
-              <a:rPr lang="en-US" sz="1250" dirty="0">
-                <a:solidFill>
-                  <a:srgbClr val="DEE0F2"/>
+              <a:rPr lang="en-US" sz="1600" dirty="0">
+                <a:solidFill>
+                  <a:srgbClr val="1E202B"/>
                 </a:solidFill>
                 <a:latin typeface="Calibri" pitchFamily="34" charset="0"/>
                 <a:ea typeface="Calibri" pitchFamily="34" charset="-122"/>
@@ -3023,7 +5471,7 @@
               </a:rPr>
               <a:t>Mr. Mkaissi Khalil, Kernel Solution &amp; Innovation</a:t>
             </a:r>
-            <a:endParaRPr lang="en-US" sz="1250" dirty="0"/>
+            <a:endParaRPr lang="en-US" sz="1600" dirty="0"/>
           </a:p>
         </p:txBody>
       </p:sp>
@@ -3035,8 +5483,8 @@
         </p:nvSpPr>
         <p:spPr>
           <a:xfrm>
-            <a:off x="640080" y="5440680"/>
-            <a:ext cx="1920240" cy="274320"/>
+            <a:off x="640080" y="5155000"/>
+            <a:ext cx="5900000" cy="240000"/>
           </a:xfrm>
           <a:prstGeom prst="rect">
             <a:avLst/>
@@ -3052,9 +5500,9 @@
               <a:buNone/>
             </a:pPr>
             <a:r>
-              <a:rPr lang="en-US" sz="950" dirty="0">
-                <a:solidFill>
-                  <a:srgbClr val="9DA1D6"/>
+              <a:rPr lang="en-US" sz="1300" dirty="0">
+                <a:solidFill>
+                  <a:srgbClr val="484C5C"/>
                 </a:solidFill>
                 <a:latin typeface="Calibri" pitchFamily="34" charset="0"/>
                 <a:ea typeface="Calibri" pitchFamily="34" charset="-122"/>
@@ -3062,7 +5510,7 @@
               </a:rPr>
               <a:t>Institution</a:t>
             </a:r>
-            <a:endParaRPr lang="en-US" sz="950" dirty="0"/>
+            <a:endParaRPr lang="en-US" sz="1300" dirty="0"/>
           </a:p>
         </p:txBody>
       </p:sp>
@@ -3074,8 +5522,8 @@
         </p:nvSpPr>
         <p:spPr>
           <a:xfrm>
-            <a:off x="2606040" y="5440680"/>
-            <a:ext cx="5486400" cy="274320"/>
+            <a:off x="640080" y="5395000"/>
+            <a:ext cx="5900000" cy="320000"/>
           </a:xfrm>
           <a:prstGeom prst="rect">
             <a:avLst/>
@@ -3091,9 +5539,9 @@
               <a:buNone/>
             </a:pPr>
             <a:r>
-              <a:rPr lang="en-US" sz="1250" dirty="0">
-                <a:solidFill>
-                  <a:srgbClr val="DEE0F2"/>
+              <a:rPr lang="en-US" sz="1600" dirty="0">
+                <a:solidFill>
+                  <a:srgbClr val="1E202B"/>
                 </a:solidFill>
                 <a:latin typeface="Calibri" pitchFamily="34" charset="0"/>
                 <a:ea typeface="Calibri" pitchFamily="34" charset="-122"/>
@@ -3101,7 +5549,7 @@
               </a:rPr>
               <a:t>ISLAIB, Licence GLSI, 2025-2026</a:t>
             </a:r>
-            <a:endParaRPr lang="en-US" sz="1250" dirty="0"/>
+            <a:endParaRPr lang="en-US" sz="1600" dirty="0"/>
           </a:p>
         </p:txBody>
       </p:sp>
@@ -3140,7 +5588,7 @@
             <a:avLst/>
           </a:prstGeom>
           <a:solidFill>
-            <a:srgbClr val="3E4258"/>
+            <a:srgbClr val="C7C9D3"/>
           </a:solidFill>
           <a:ln/>
         </p:spPr>
@@ -3160,7 +5608,7 @@
             <a:avLst/>
           </a:prstGeom>
           <a:solidFill>
-            <a:srgbClr val="3E4258"/>
+            <a:srgbClr val="C7C9D3"/>
           </a:solidFill>
           <a:ln/>
         </p:spPr>
@@ -3180,7 +5628,7 @@
             <a:avLst/>
           </a:prstGeom>
           <a:solidFill>
-            <a:srgbClr val="3E4258"/>
+            <a:srgbClr val="C7C9D3"/>
           </a:solidFill>
           <a:ln/>
         </p:spPr>
@@ -3200,7 +5648,7 @@
             <a:avLst/>
           </a:prstGeom>
           <a:solidFill>
-            <a:srgbClr val="3E4258"/>
+            <a:srgbClr val="C7C9D3"/>
           </a:solidFill>
           <a:ln/>
         </p:spPr>
@@ -3220,7 +5668,7 @@
             <a:avLst/>
           </a:prstGeom>
           <a:solidFill>
-            <a:srgbClr val="3E4258"/>
+            <a:srgbClr val="C7C9D3"/>
           </a:solidFill>
           <a:ln/>
         </p:spPr>
@@ -3240,7 +5688,7 @@
             <a:avLst/>
           </a:prstGeom>
           <a:solidFill>
-            <a:srgbClr val="3E4258"/>
+            <a:srgbClr val="C7C9D3"/>
           </a:solidFill>
           <a:ln/>
         </p:spPr>
@@ -3260,7 +5708,7 @@
             <a:avLst/>
           </a:prstGeom>
           <a:solidFill>
-            <a:srgbClr val="3E4258"/>
+            <a:srgbClr val="C7C9D3"/>
           </a:solidFill>
           <a:ln/>
         </p:spPr>
@@ -3280,7 +5728,7 @@
             <a:avLst/>
           </a:prstGeom>
           <a:solidFill>
-            <a:srgbClr val="3E4258"/>
+            <a:srgbClr val="C7C9D3"/>
           </a:solidFill>
           <a:ln/>
         </p:spPr>
@@ -3300,7 +5748,7 @@
             <a:avLst/>
           </a:prstGeom>
           <a:solidFill>
-            <a:srgbClr val="3E4258"/>
+            <a:srgbClr val="C7C9D3"/>
           </a:solidFill>
           <a:ln/>
         </p:spPr>
@@ -3320,7 +5768,7 @@
             <a:avLst/>
           </a:prstGeom>
           <a:solidFill>
-            <a:srgbClr val="3E4258"/>
+            <a:srgbClr val="C7C9D3"/>
           </a:solidFill>
           <a:ln/>
         </p:spPr>
@@ -3340,7 +5788,7 @@
             <a:avLst/>
           </a:prstGeom>
           <a:solidFill>
-            <a:srgbClr val="3E4258"/>
+            <a:srgbClr val="C7C9D3"/>
           </a:solidFill>
           <a:ln/>
         </p:spPr>
@@ -3360,7 +5808,7 @@
             <a:avLst/>
           </a:prstGeom>
           <a:solidFill>
-            <a:srgbClr val="3E4258"/>
+            <a:srgbClr val="C7C9D3"/>
           </a:solidFill>
           <a:ln/>
         </p:spPr>
@@ -3380,7 +5828,7 @@
             <a:avLst/>
           </a:prstGeom>
           <a:solidFill>
-            <a:srgbClr val="3E4258"/>
+            <a:srgbClr val="C7C9D3"/>
           </a:solidFill>
           <a:ln/>
         </p:spPr>
@@ -3400,7 +5848,7 @@
             <a:avLst/>
           </a:prstGeom>
           <a:solidFill>
-            <a:srgbClr val="3E4258"/>
+            <a:srgbClr val="C7C9D3"/>
           </a:solidFill>
           <a:ln/>
         </p:spPr>
@@ -3420,7 +5868,7 @@
             <a:avLst/>
           </a:prstGeom>
           <a:solidFill>
-            <a:srgbClr val="3E4258"/>
+            <a:srgbClr val="C7C9D3"/>
           </a:solidFill>
           <a:ln/>
         </p:spPr>
@@ -3440,7 +5888,7 @@
             <a:avLst/>
           </a:prstGeom>
           <a:solidFill>
-            <a:srgbClr val="3E4258"/>
+            <a:srgbClr val="C7C9D3"/>
           </a:solidFill>
           <a:ln/>
         </p:spPr>
@@ -3460,7 +5908,7 @@
             <a:avLst/>
           </a:prstGeom>
           <a:solidFill>
-            <a:srgbClr val="3E4258"/>
+            <a:srgbClr val="C7C9D3"/>
           </a:solidFill>
           <a:ln/>
         </p:spPr>
@@ -3480,7 +5928,7 @@
             <a:avLst/>
           </a:prstGeom>
           <a:solidFill>
-            <a:srgbClr val="3E4258"/>
+            <a:srgbClr val="C7C9D3"/>
           </a:solidFill>
           <a:ln/>
         </p:spPr>
@@ -3512,7 +5960,7 @@
             <a:r>
               <a:rPr lang="en-US" sz="1150" b="1" dirty="0">
                 <a:solidFill>
-                  <a:srgbClr val="F2F2F7"/>
+                  <a:srgbClr val="1E202B"/>
                 </a:solidFill>
                 <a:latin typeface="Calibri" pitchFamily="34" charset="0"/>
                 <a:ea typeface="Calibri" pitchFamily="34" charset="-122"/>
@@ -12597,7 +15045,7 @@
     <p:bg>
       <p:bgPr>
         <a:solidFill>
-          <a:srgbClr val="14161F"/>
+          <a:srgbClr val="FFFFFF"/>
         </a:solidFill>
       </p:bgPr>
     </p:bg>
@@ -12623,7 +15071,7 @@
         </p:nvSpPr>
         <p:spPr>
           <a:xfrm>
-            <a:off x="640080" y="1920240"/>
+            <a:off x="731520" y="1550000"/>
             <a:ext cx="457200" cy="73152"/>
           </a:xfrm>
           <a:prstGeom prst="rect">
@@ -12643,8 +15091,8 @@
         </p:nvSpPr>
         <p:spPr>
           <a:xfrm>
-            <a:off x="640080" y="2103120"/>
-            <a:ext cx="5486400" cy="320040"/>
+            <a:off x="640080" y="1720000"/>
+            <a:ext cx="5486400" cy="360000"/>
           </a:xfrm>
           <a:prstGeom prst="rect">
             <a:avLst/>
@@ -12660,9 +15108,9 @@
               <a:buNone/>
             </a:pPr>
             <a:r>
-              <a:rPr lang="en-US" sz="1300" b="1" dirty="0">
-                <a:solidFill>
-                  <a:srgbClr val="F2F2F7"/>
+              <a:rPr lang="en-US" sz="1600" b="1" dirty="0">
+                <a:solidFill>
+                  <a:srgbClr val="4F46E5"/>
                 </a:solidFill>
                 <a:latin typeface="Calibri" pitchFamily="34" charset="0"/>
                 <a:ea typeface="Calibri" pitchFamily="34" charset="-122"/>
@@ -12670,7 +15118,7 @@
               </a:rPr>
               <a:t>Conclusion</a:t>
             </a:r>
-            <a:endParaRPr lang="en-US" sz="1300" dirty="0"/>
+            <a:endParaRPr lang="en-US" sz="1600" dirty="0"/>
           </a:p>
         </p:txBody>
       </p:sp>
@@ -12682,8 +15130,8 @@
         </p:nvSpPr>
         <p:spPr>
           <a:xfrm>
-            <a:off x="640080" y="2423160"/>
-            <a:ext cx="9875520" cy="1188720"/>
+            <a:off x="640080" y="2120000"/>
+            <a:ext cx="10911535" cy="850000"/>
           </a:xfrm>
           <a:prstGeom prst="rect">
             <a:avLst/>
@@ -12699,9 +15147,9 @@
               <a:buNone/>
             </a:pPr>
             <a:r>
-              <a:rPr lang="en-US" sz="3200" b="1" dirty="0">
-                <a:solidFill>
-                  <a:srgbClr val="FFFFFF"/>
+              <a:rPr lang="en-US" sz="3600" b="1" dirty="0">
+                <a:solidFill>
+                  <a:srgbClr val="1E202B"/>
                 </a:solidFill>
                 <a:latin typeface="Cambria" pitchFamily="34" charset="0"/>
                 <a:ea typeface="Cambria" pitchFamily="34" charset="-122"/>
@@ -12709,7 +15157,7 @@
               </a:rPr>
               <a:t>A complete platform, built solo, in seven weeks</a:t>
             </a:r>
-            <a:endParaRPr lang="en-US" sz="3200" dirty="0"/>
+            <a:endParaRPr lang="en-US" sz="3600" dirty="0"/>
           </a:p>
         </p:txBody>
       </p:sp>
@@ -12721,8 +15169,8 @@
         </p:nvSpPr>
         <p:spPr>
           <a:xfrm>
-            <a:off x="640080" y="3611880"/>
-            <a:ext cx="8778240" cy="960120"/>
+            <a:off x="640080" y="3150000"/>
+            <a:ext cx="10911535" cy="1300000"/>
           </a:xfrm>
           <a:prstGeom prst="rect">
             <a:avLst/>
@@ -12741,9 +15189,9 @@
               <a:buNone/>
             </a:pPr>
             <a:r>
-              <a:rPr lang="en-US" sz="1350" dirty="0">
-                <a:solidFill>
-                  <a:srgbClr val="D6D8F5"/>
+              <a:rPr lang="en-US" sz="1900" dirty="0">
+                <a:solidFill>
+                  <a:srgbClr val="484C5C"/>
                 </a:solidFill>
                 <a:latin typeface="Calibri" pitchFamily="34" charset="0"/>
                 <a:ea typeface="Calibri" pitchFamily="34" charset="-122"/>
@@ -12751,7 +15199,7 @@
               </a:rPr>
               <a:t>Synkro meets every objective set out at the start of this internship: role-aware collaboration, real-time updates, and a full administration layer, delivered through a disciplined, sprint-based process from requirements to a working product.</a:t>
             </a:r>
-            <a:endParaRPr lang="en-US" sz="1350" dirty="0"/>
+            <a:endParaRPr lang="en-US" sz="1900" dirty="0"/>
           </a:p>
         </p:txBody>
       </p:sp>
@@ -12763,8 +15211,8 @@
         </p:nvSpPr>
         <p:spPr>
           <a:xfrm>
-            <a:off x="640080" y="4572000"/>
-            <a:ext cx="8778240" cy="914400"/>
+            <a:off x="640080" y="4600000"/>
+            <a:ext cx="10911535" cy="1000000"/>
           </a:xfrm>
           <a:prstGeom prst="rect">
             <a:avLst/>
@@ -12783,9 +15231,9 @@
               <a:buNone/>
             </a:pPr>
             <a:r>
-              <a:rPr lang="en-US" sz="1350" b="1" dirty="0">
-                <a:solidFill>
-                  <a:srgbClr val="FFFFFF"/>
+              <a:rPr lang="en-US" sz="1900" b="1" dirty="0">
+                <a:solidFill>
+                  <a:srgbClr val="1E202B"/>
                 </a:solidFill>
                 <a:latin typeface="Calibri" pitchFamily="34" charset="0"/>
                 <a:ea typeface="Calibri" pitchFamily="34" charset="-122"/>
@@ -12793,7 +15241,7 @@
               </a:rPr>
               <a:t>This internship was a complete, hands-on exercise in software engineering: not just a product, but the judgment built while shipping it under real constraints.</a:t>
             </a:r>
-            <a:endParaRPr lang="en-US" sz="1350" dirty="0"/>
+            <a:endParaRPr lang="en-US" sz="1900" dirty="0"/>
           </a:p>
         </p:txBody>
       </p:sp>
@@ -13172,7 +15620,7 @@
             <a:avLst/>
           </a:prstGeom>
           <a:solidFill>
-            <a:srgbClr val="3E4258"/>
+            <a:srgbClr val="C7C9D3"/>
           </a:solidFill>
           <a:ln/>
         </p:spPr>
@@ -13204,7 +15652,7 @@
             <a:r>
               <a:rPr lang="en-US" sz="1150" b="1" dirty="0">
                 <a:solidFill>
-                  <a:srgbClr val="F2F2F7"/>
+                  <a:srgbClr val="1E202B"/>
                 </a:solidFill>
                 <a:latin typeface="Calibri" pitchFamily="34" charset="0"/>
                 <a:ea typeface="Calibri" pitchFamily="34" charset="-122"/>
@@ -13230,7 +15678,7 @@
     <p:bg>
       <p:bgPr>
         <a:solidFill>
-          <a:srgbClr val="14161F"/>
+          <a:srgbClr val="FFFFFF"/>
         </a:solidFill>
       </p:bgPr>
     </p:bg>
@@ -13257,7 +15705,7 @@
         <p:spPr>
           <a:xfrm>
             <a:off x="640080" y="2743200"/>
-            <a:ext cx="9144000" cy="914400"/>
+            <a:ext cx="9144000" cy="1000000"/>
           </a:xfrm>
           <a:prstGeom prst="rect">
             <a:avLst/>
@@ -13273,9 +15721,9 @@
               <a:buNone/>
             </a:pPr>
             <a:r>
-              <a:rPr lang="en-US" sz="4600" b="1" dirty="0">
-                <a:solidFill>
-                  <a:srgbClr val="FFFFFF"/>
+              <a:rPr lang="en-US" sz="5400" b="1" dirty="0">
+                <a:solidFill>
+                  <a:srgbClr val="1E202B"/>
                 </a:solidFill>
                 <a:latin typeface="Cambria" pitchFamily="34" charset="0"/>
                 <a:ea typeface="Cambria" pitchFamily="34" charset="-122"/>
@@ -13283,7 +15731,7 @@
               </a:rPr>
               <a:t>Thank you</a:t>
             </a:r>
-            <a:endParaRPr lang="en-US" sz="4600" dirty="0"/>
+            <a:endParaRPr lang="en-US" sz="5400" dirty="0"/>
           </a:p>
         </p:txBody>
       </p:sp>
@@ -13295,8 +15743,8 @@
         </p:nvSpPr>
         <p:spPr>
           <a:xfrm>
-            <a:off x="640080" y="3566160"/>
-            <a:ext cx="9144000" cy="502920"/>
+            <a:off x="640080" y="3720000"/>
+            <a:ext cx="9144000" cy="550000"/>
           </a:xfrm>
           <a:prstGeom prst="rect">
             <a:avLst/>
@@ -13312,9 +15760,9 @@
               <a:buNone/>
             </a:pPr>
             <a:r>
-              <a:rPr lang="en-US" sz="1600" dirty="0">
-                <a:solidFill>
-                  <a:srgbClr val="D6D8F5"/>
+              <a:rPr lang="en-US" sz="2400" dirty="0">
+                <a:solidFill>
+                  <a:srgbClr val="484C5C"/>
                 </a:solidFill>
                 <a:latin typeface="Calibri" pitchFamily="34" charset="0"/>
                 <a:ea typeface="Calibri" pitchFamily="34" charset="-122"/>
@@ -13322,7 +15770,7 @@
               </a:rPr>
               <a:t>Questions &amp; discussion</a:t>
             </a:r>
-            <a:endParaRPr lang="en-US" sz="1600" dirty="0"/>
+            <a:endParaRPr lang="en-US" sz="2400" dirty="0"/>
           </a:p>
         </p:txBody>
       </p:sp>
@@ -13334,7 +15782,7 @@
         </p:nvSpPr>
         <p:spPr>
           <a:xfrm>
-            <a:off x="640080" y="5760720"/>
+            <a:off x="731520" y="5420000"/>
             <a:ext cx="2011680" cy="0"/>
           </a:xfrm>
           <a:prstGeom prst="line">
@@ -13343,7 +15791,7 @@
           <a:noFill/>
           <a:ln w="12700">
             <a:solidFill>
-              <a:srgbClr val="3E4258"/>
+              <a:srgbClr val="9AA0B4"/>
             </a:solidFill>
             <a:prstDash val="solid"/>
           </a:ln>
@@ -13357,8 +15805,8 @@
         </p:nvSpPr>
         <p:spPr>
           <a:xfrm>
-            <a:off x="640080" y="5870448"/>
-            <a:ext cx="3657600" cy="274320"/>
+            <a:off x="640080" y="5520000"/>
+            <a:ext cx="5486400" cy="340000"/>
           </a:xfrm>
           <a:prstGeom prst="rect">
             <a:avLst/>
@@ -13374,9 +15822,9 @@
               <a:buNone/>
             </a:pPr>
             <a:r>
-              <a:rPr lang="en-US" sz="1100" dirty="0">
-                <a:solidFill>
-                  <a:srgbClr val="DEE0F2"/>
+              <a:rPr lang="en-US" sz="1600" dirty="0">
+                <a:solidFill>
+                  <a:srgbClr val="1E202B"/>
                 </a:solidFill>
                 <a:latin typeface="Calibri" pitchFamily="34" charset="0"/>
                 <a:ea typeface="Calibri" pitchFamily="34" charset="-122"/>
@@ -13384,7 +15832,7 @@
               </a:rPr>
               <a:t>Adem Ouerhani</a:t>
             </a:r>
-            <a:endParaRPr lang="en-US" sz="1100" dirty="0"/>
+            <a:endParaRPr lang="en-US" sz="1600" dirty="0"/>
           </a:p>
         </p:txBody>
       </p:sp>
@@ -13396,8 +15844,8 @@
         </p:nvSpPr>
         <p:spPr>
           <a:xfrm>
-            <a:off x="640080" y="6126480"/>
-            <a:ext cx="3657600" cy="274320"/>
+            <a:off x="640080" y="5860000"/>
+            <a:ext cx="5486400" cy="320000"/>
           </a:xfrm>
           <a:prstGeom prst="rect">
             <a:avLst/>
@@ -13413,9 +15861,9 @@
               <a:buNone/>
             </a:pPr>
             <a:r>
-              <a:rPr lang="en-US" sz="950" dirty="0">
-                <a:solidFill>
-                  <a:srgbClr val="C7CAE3"/>
+              <a:rPr lang="en-US" sz="1400" dirty="0">
+                <a:solidFill>
+                  <a:srgbClr val="484C5C"/>
                 </a:solidFill>
                 <a:latin typeface="Calibri" pitchFamily="34" charset="0"/>
                 <a:ea typeface="Calibri" pitchFamily="34" charset="-122"/>
@@ -13423,7 +15871,7 @@
               </a:rPr>
               <a:t>Synkro, ISLAIB, Licence GLSI</a:t>
             </a:r>
-            <a:endParaRPr lang="en-US" sz="950" dirty="0"/>
+            <a:endParaRPr lang="en-US" sz="1400" dirty="0"/>
           </a:p>
         </p:txBody>
       </p:sp>
@@ -13834,7 +16282,7 @@
             <a:r>
               <a:rPr lang="en-US" sz="1150" b="1" dirty="0">
                 <a:solidFill>
-                  <a:srgbClr val="F2F2F7"/>
+                  <a:srgbClr val="1E202B"/>
                 </a:solidFill>
                 <a:latin typeface="Calibri" pitchFamily="34" charset="0"/>
                 <a:ea typeface="Calibri" pitchFamily="34" charset="-122"/>

</xml_diff>